<commit_message>
fix(nodeslide): close live geometry regressions
</commit_message>
<xml_diff>
--- a/evidence/scene-continuity-v2/generated/risk-committee-scene-continuity.pptx
+++ b/evidence/scene-continuity-v2/generated/risk-committee-scene-continuity.pptx
@@ -702,14 +702,11 @@
           <a:p>
             <a:r>
               <a:rPr lang="en-US" dirty="0"/>
-              <a:t>Narrative role: Proof. Composition grammar: scene-stage. Keep the spoken transition focused on "Agree how success will be judged before the next decision."
+              <a:t>Narrative role: Proof. Composition grammar: asymmetric-editorial. Keep the spoken transition focused on "Agree how success will be judged before the next decision."
 Evidence note: Content is based on the supplied creation brief. Illustrative examples are not independently verified; replace them with measured evidence before external publication.
 NodeSlide sources
 [source_26bf56ae628059912a6bb17d7978e1df] Build exactly 12 slides for a risk committee deciding whether an AI release may… — creation brief
 Citation: Build exactly 12 slides for a risk committee deciding whether an AI release may proceed. Use only supplied qualitative evidence. Move the guarded threshold from exposed uncertainty through inspection to an explicit release state. Do not invent figures, weights, thresholds, formulas, dates, or operating rules.
-Disclaimer: Internal working material
-[source_b8f449739f99d11a2b90824fc411ebb2] Brief success criteria
-Citation: Preserve all twelve narrative jobs; Separate supplied evidence from open assumptions; Name the decision owner and next checkpoint
 Disclaimer: Internal working material</a:t>
             </a:r>
             <a:endParaRPr lang="en-US" dirty="0"/>
@@ -1173,11 +1170,14 @@
           <a:p>
             <a:r>
               <a:rPr lang="en-US" dirty="0"/>
-              <a:t>Narrative role: Evidence / 05. Composition grammar: comparison-field. Keep the spoken transition focused on "Define proof before asking for commitment."
+              <a:t>Narrative role: Evidence / 05. Composition grammar: scene-stage. Keep the spoken transition focused on "Define proof before asking for commitment."
 Evidence note: Content is based on the supplied creation brief. Illustrative examples are not independently verified; replace them with measured evidence before external publication.
 NodeSlide sources
 [source_26bf56ae628059912a6bb17d7978e1df] Build exactly 12 slides for a risk committee deciding whether an AI release may… — creation brief
 Citation: Build exactly 12 slides for a risk committee deciding whether an AI release may proceed. Use only supplied qualitative evidence. Move the guarded threshold from exposed uncertainty through inspection to an explicit release state. Do not invent figures, weights, thresholds, formulas, dates, or operating rules.
+Disclaimer: Internal working material
+[source_b8f449739f99d11a2b90824fc411ebb2] Brief success criteria
+Citation: Preserve all twelve narrative jobs; Separate supplied evidence from open assumptions; Name the decision owner and next checkpoint
 Disclaimer: Internal working material</a:t>
             </a:r>
             <a:endParaRPr lang="en-US" dirty="0"/>
@@ -1266,11 +1266,14 @@
           <a:p>
             <a:r>
               <a:rPr lang="en-US" dirty="0"/>
-              <a:t>Narrative role: Delivery / 06. Composition grammar: asymmetric-editorial. Keep the spoken transition focused on "Start narrow, learn quickly, and preserve room to adapt."
+              <a:t>Narrative role: Delivery / 06. Composition grammar: scene-stage. Keep the spoken transition focused on "Start narrow, learn quickly, and preserve room to adapt."
 Evidence note: Content is based on the supplied creation brief. Illustrative examples are not independently verified; replace them with measured evidence before external publication.
 NodeSlide sources
 [source_26bf56ae628059912a6bb17d7978e1df] Build exactly 12 slides for a risk committee deciding whether an AI release may… — creation brief
 Citation: Build exactly 12 slides for a risk committee deciding whether an AI release may proceed. Use only supplied qualitative evidence. Move the guarded threshold from exposed uncertainty through inspection to an explicit release state. Do not invent figures, weights, thresholds, formulas, dates, or operating rules.
+Disclaimer: Internal working material
+[source_b8f449739f99d11a2b90824fc411ebb2] Brief success criteria
+Citation: Preserve all twelve narrative jobs; Separate supplied evidence from open assumptions; Name the decision owner and next checkpoint
 Disclaimer: Internal working material</a:t>
             </a:r>
             <a:endParaRPr lang="en-US" dirty="0"/>
@@ -2349,8 +2352,8 @@
         </p:nvSpPr>
         <p:spPr>
           <a:xfrm>
-            <a:off x="731502" y="1371600"/>
-            <a:ext cx="5852014" cy="3840480"/>
+            <a:off x="731502" y="1234440"/>
+            <a:ext cx="5852014" cy="4114800"/>
           </a:xfrm>
           <a:prstGeom prst="roundRect">
             <a:avLst/>
@@ -2378,8 +2381,8 @@
         </p:nvSpPr>
         <p:spPr>
           <a:xfrm>
-            <a:off x="2078684" y="1762506"/>
-            <a:ext cx="241396" cy="2400300"/>
+            <a:off x="2167683" y="1645920"/>
+            <a:ext cx="262121" cy="3429000"/>
           </a:xfrm>
           <a:prstGeom prst="roundRect">
             <a:avLst/>
@@ -2407,8 +2410,8 @@
         </p:nvSpPr>
         <p:spPr>
           <a:xfrm>
-            <a:off x="4781583" y="1762506"/>
-            <a:ext cx="241396" cy="2400300"/>
+            <a:off x="5103444" y="1645920"/>
+            <a:ext cx="262121" cy="3429000"/>
           </a:xfrm>
           <a:prstGeom prst="roundRect">
             <a:avLst/>
@@ -2436,8 +2439,8 @@
         </p:nvSpPr>
         <p:spPr>
           <a:xfrm>
-            <a:off x="2320080" y="3490722"/>
-            <a:ext cx="2463942" cy="216027"/>
+            <a:off x="2429805" y="4114800"/>
+            <a:ext cx="2676077" cy="308610"/>
           </a:xfrm>
           <a:prstGeom prst="roundRect">
             <a:avLst/>
@@ -2465,8 +2468,8 @@
         </p:nvSpPr>
         <p:spPr>
           <a:xfrm>
-            <a:off x="4301230" y="3202686"/>
-            <a:ext cx="442559" cy="528066"/>
+            <a:off x="4581639" y="3703320"/>
+            <a:ext cx="480353" cy="754380"/>
           </a:xfrm>
           <a:prstGeom prst="roundRect">
             <a:avLst/>
@@ -2626,8 +2629,8 @@
         </p:nvSpPr>
         <p:spPr>
           <a:xfrm>
-            <a:off x="7315017" y="5417820"/>
-            <a:ext cx="4145176" cy="548640"/>
+            <a:off x="7315017" y="5280660"/>
+            <a:ext cx="4145176" cy="754380"/>
           </a:xfrm>
           <a:prstGeom prst="rect">
             <a:avLst/>
@@ -2813,153 +2816,14 @@
       </p:sp>
       <p:sp>
         <p:nvSpPr>
-          <p:cNvPr id="3" name="element_cbf20ee37be6dd144c4a017ab3b8fd0c"/>
-          <p:cNvSpPr/>
-          <p:nvPr/>
-        </p:nvSpPr>
-        <p:spPr>
-          <a:xfrm>
-            <a:off x="5608180" y="1371600"/>
-            <a:ext cx="5852014" cy="3840480"/>
-          </a:xfrm>
-          <a:prstGeom prst="roundRect">
-            <a:avLst/>
-          </a:prstGeom>
-          <a:solidFill>
-            <a:srgbClr val="F2DED3">
-              <a:alpha val="22000"/>
-            </a:srgbClr>
-          </a:solidFill>
-          <a:ln w="12700">
-            <a:solidFill>
-              <a:srgbClr val="FFFFFF">
-                <a:alpha val="0"/>
-              </a:srgbClr>
-            </a:solidFill>
-            <a:prstDash val="solid"/>
-          </a:ln>
-        </p:spPr>
-      </p:sp>
-      <p:sp>
-        <p:nvSpPr>
-          <p:cNvPr id="4" name="element_b2854094ce033f66e0f2567d3da73b0e"/>
-          <p:cNvSpPr/>
-          <p:nvPr/>
-        </p:nvSpPr>
-        <p:spPr>
-          <a:xfrm>
-            <a:off x="6866363" y="1762506"/>
-            <a:ext cx="241396" cy="2400300"/>
-          </a:xfrm>
-          <a:prstGeom prst="roundRect">
-            <a:avLst/>
-          </a:prstGeom>
-          <a:solidFill>
-            <a:srgbClr val="34452C"/>
-          </a:solidFill>
-          <a:ln w="12700">
-            <a:solidFill>
-              <a:srgbClr val="FFFFFF">
-                <a:alpha val="0"/>
-              </a:srgbClr>
-            </a:solidFill>
-            <a:prstDash val="solid"/>
-          </a:ln>
-        </p:spPr>
-      </p:sp>
-      <p:sp>
-        <p:nvSpPr>
-          <p:cNvPr id="5" name="element_48402ebbe3a8ec3b2a5f26360b92c1dc"/>
-          <p:cNvSpPr/>
-          <p:nvPr/>
-        </p:nvSpPr>
-        <p:spPr>
-          <a:xfrm>
-            <a:off x="9747260" y="1762506"/>
-            <a:ext cx="241396" cy="2400300"/>
-          </a:xfrm>
-          <a:prstGeom prst="roundRect">
-            <a:avLst/>
-          </a:prstGeom>
-          <a:solidFill>
-            <a:srgbClr val="34452C"/>
-          </a:solidFill>
-          <a:ln w="12700">
-            <a:solidFill>
-              <a:srgbClr val="FFFFFF">
-                <a:alpha val="0"/>
-              </a:srgbClr>
-            </a:solidFill>
-            <a:prstDash val="solid"/>
-          </a:ln>
-        </p:spPr>
-      </p:sp>
-      <p:sp>
-        <p:nvSpPr>
-          <p:cNvPr id="6" name="element_25e116853f5c838cfc7009e9ec971251"/>
-          <p:cNvSpPr/>
-          <p:nvPr/>
-        </p:nvSpPr>
-        <p:spPr>
-          <a:xfrm>
-            <a:off x="7107758" y="3490722"/>
-            <a:ext cx="2640721" cy="216027"/>
-          </a:xfrm>
-          <a:prstGeom prst="roundRect">
-            <a:avLst/>
-          </a:prstGeom>
-          <a:solidFill>
-            <a:srgbClr val="F2DED3">
-              <a:alpha val="74000"/>
-            </a:srgbClr>
-          </a:solidFill>
-          <a:ln w="12700">
-            <a:solidFill>
-              <a:srgbClr val="FFFFFF">
-                <a:alpha val="0"/>
-              </a:srgbClr>
-            </a:solidFill>
-            <a:prstDash val="solid"/>
-          </a:ln>
-        </p:spPr>
-      </p:sp>
-      <p:sp>
-        <p:nvSpPr>
-          <p:cNvPr id="7" name="element_211bb930c058f5f9c6b025ea955129de"/>
-          <p:cNvSpPr/>
-          <p:nvPr/>
-        </p:nvSpPr>
-        <p:spPr>
-          <a:xfrm>
-            <a:off x="9497331" y="3202686"/>
-            <a:ext cx="442559" cy="528066"/>
-          </a:xfrm>
-          <a:prstGeom prst="roundRect">
-            <a:avLst/>
-          </a:prstGeom>
-          <a:solidFill>
-            <a:srgbClr val="B44A2D"/>
-          </a:solidFill>
-          <a:ln w="12700">
-            <a:solidFill>
-              <a:srgbClr val="FFFFFF">
-                <a:alpha val="0"/>
-              </a:srgbClr>
-            </a:solidFill>
-            <a:prstDash val="solid"/>
-          </a:ln>
-        </p:spPr>
-      </p:sp>
-      <p:sp>
-        <p:nvSpPr>
-          <p:cNvPr id="8" name="element_7992db25ff6c1ed0fdaffccc48b775c3"/>
+          <p:cNvPr id="3" name="element_7992db25ff6c1ed0fdaffccc48b775c3"/>
           <p:cNvSpPr txBox="1"/>
           <p:nvPr/>
         </p:nvSpPr>
         <p:spPr>
           <a:xfrm>
-            <a:off x="731502" y="445770"/>
-            <a:ext cx="3657509" cy="342900"/>
+            <a:off x="6461598" y="445770"/>
+            <a:ext cx="4876678" cy="342900"/>
           </a:xfrm>
           <a:prstGeom prst="rect">
             <a:avLst/>
@@ -2996,14 +2860,14 @@
       </p:sp>
       <p:sp>
         <p:nvSpPr>
-          <p:cNvPr id="9" name="element_47b50223155bcfc9b1a97c2b9c8f2e28"/>
+          <p:cNvPr id="4" name="element_47b50223155bcfc9b1a97c2b9c8f2e28"/>
           <p:cNvSpPr txBox="1"/>
           <p:nvPr/>
         </p:nvSpPr>
         <p:spPr>
           <a:xfrm>
-            <a:off x="731502" y="1234440"/>
-            <a:ext cx="4145176" cy="2311146"/>
+            <a:off x="853419" y="1097280"/>
+            <a:ext cx="10484858" cy="1234440"/>
           </a:xfrm>
           <a:prstGeom prst="rect">
             <a:avLst/>
@@ -3019,12 +2883,12 @@
           <a:p>
             <a:pPr algn="l" indent="0" marL="0">
               <a:lnSpc>
-                <a:spcPct val="104000"/>
+                <a:spcPct val="105000"/>
               </a:lnSpc>
               <a:buNone/>
             </a:pPr>
             <a:r>
-              <a:rPr lang="en-US" sz="3500" b="1" spc="-50" kern="0" dirty="0">
+              <a:rPr lang="en-US" sz="4200" b="1" spc="-60" kern="0" dirty="0">
                 <a:solidFill>
                   <a:srgbClr val="26221D"/>
                 </a:solidFill>
@@ -3034,20 +2898,20 @@
               </a:rPr>
               <a:t>Agree how success will be judged before the next decision.</a:t>
             </a:r>
-            <a:endParaRPr lang="en-US" sz="3500" dirty="0"/>
-          </a:p>
-        </p:txBody>
-      </p:sp>
-      <p:sp>
-        <p:nvSpPr>
-          <p:cNvPr id="10" name="element_18d6c8ab2ea21a54310780349c453eb5"/>
+            <a:endParaRPr lang="en-US" sz="4200" dirty="0"/>
+          </a:p>
+        </p:txBody>
+      </p:sp>
+      <p:sp>
+        <p:nvSpPr>
+          <p:cNvPr id="5" name="element_18d6c8ab2ea21a54310780349c453eb5"/>
           <p:cNvSpPr txBox="1"/>
           <p:nvPr/>
         </p:nvSpPr>
         <p:spPr>
           <a:xfrm>
-            <a:off x="731502" y="3785616"/>
-            <a:ext cx="4145176" cy="1357884"/>
+            <a:off x="1706837" y="2743200"/>
+            <a:ext cx="9631439" cy="1028700"/>
           </a:xfrm>
           <a:prstGeom prst="rect">
             <a:avLst/>
@@ -3063,12 +2927,12 @@
           <a:p>
             <a:pPr algn="l" indent="0" marL="0">
               <a:lnSpc>
-                <a:spcPct val="138000"/>
+                <a:spcPct val="135000"/>
               </a:lnSpc>
               <a:buNone/>
             </a:pPr>
             <a:r>
-              <a:rPr lang="en-US" sz="1600" dirty="0">
+              <a:rPr lang="en-US" sz="1800" dirty="0">
                 <a:solidFill>
                   <a:srgbClr val="756B61"/>
                 </a:solidFill>
@@ -3078,20 +2942,20 @@
               </a:rPr>
               <a:t>Use the supplied success criteria as review questions; do not turn them into invented scores or weights.</a:t>
             </a:r>
-            <a:endParaRPr lang="en-US" sz="1600" dirty="0"/>
-          </a:p>
-        </p:txBody>
-      </p:sp>
-      <p:sp>
-        <p:nvSpPr>
-          <p:cNvPr id="11" name="element_bda5bc580a5647bac7ed278aa99ba3fb"/>
+            <a:endParaRPr lang="en-US" sz="1800" dirty="0"/>
+          </a:p>
+        </p:txBody>
+      </p:sp>
+      <p:sp>
+        <p:nvSpPr>
+          <p:cNvPr id="6" name="element_41a16164cc258ac30956cbd4640306f6"/>
           <p:cNvSpPr txBox="1"/>
           <p:nvPr/>
         </p:nvSpPr>
         <p:spPr>
           <a:xfrm>
-            <a:off x="731502" y="5417820"/>
-            <a:ext cx="4145176" cy="548640"/>
+            <a:off x="975336" y="3909060"/>
+            <a:ext cx="4023259" cy="518465"/>
           </a:xfrm>
           <a:prstGeom prst="rect">
             <a:avLst/>
@@ -3100,41 +2964,239 @@
           <a:ln/>
         </p:spPr>
         <p:txBody>
-          <a:bodyPr wrap="square" lIns="152400" tIns="152400" rIns="152400" bIns="152400" rtlCol="0" anchor="t">
+          <a:bodyPr wrap="square" lIns="0" tIns="0" rIns="0" bIns="0" rtlCol="0" anchor="t">
             <a:normAutofit/>
           </a:bodyPr>
           <a:lstStyle/>
           <a:p>
             <a:pPr algn="l" indent="0" marL="0">
               <a:lnSpc>
-                <a:spcPct val="125000"/>
+                <a:spcPct val="120000"/>
               </a:lnSpc>
               <a:buNone/>
             </a:pPr>
             <a:r>
-              <a:rPr lang="en-US" sz="1600" b="1" dirty="0">
+              <a:rPr lang="en-US" sz="1700" dirty="0">
                 <a:solidFill>
-                  <a:srgbClr val="34452C"/>
+                  <a:srgbClr val="26221D"/>
                 </a:solidFill>
                 <a:latin typeface="Geist Variable" pitchFamily="34" charset="0"/>
                 <a:ea typeface="Geist Variable" pitchFamily="34" charset="-122"/>
                 <a:cs typeface="Geist Variable" pitchFamily="34" charset="-120"/>
               </a:rPr>
-              <a:t>Preserve all twelve narrative jobs</a:t>
-            </a:r>
-            <a:endParaRPr lang="en-US" sz="1600" dirty="0"/>
-          </a:p>
-        </p:txBody>
-      </p:sp>
-      <p:sp>
-        <p:nvSpPr>
-          <p:cNvPr id="12" name="element_d7b507fb8a349bc29e7f736b6a316300"/>
+              <a:t>01  Preserve all twelve narrative jobs</a:t>
+            </a:r>
+            <a:endParaRPr lang="en-US" sz="1700" dirty="0"/>
+          </a:p>
+        </p:txBody>
+      </p:sp>
+      <p:sp>
+        <p:nvSpPr>
+          <p:cNvPr id="7" name="element_af08544760b746ffbd9c026b0123c4ba"/>
           <p:cNvSpPr txBox="1"/>
           <p:nvPr/>
         </p:nvSpPr>
         <p:spPr>
           <a:xfrm>
-            <a:off x="853419" y="6377940"/>
+            <a:off x="975336" y="4633265"/>
+            <a:ext cx="4023259" cy="518465"/>
+          </a:xfrm>
+          <a:prstGeom prst="rect">
+            <a:avLst/>
+          </a:prstGeom>
+          <a:noFill/>
+          <a:ln/>
+        </p:spPr>
+        <p:txBody>
+          <a:bodyPr wrap="square" lIns="0" tIns="0" rIns="0" bIns="0" rtlCol="0" anchor="t">
+            <a:normAutofit/>
+          </a:bodyPr>
+          <a:lstStyle/>
+          <a:p>
+            <a:pPr algn="l" indent="0" marL="0">
+              <a:lnSpc>
+                <a:spcPct val="120000"/>
+              </a:lnSpc>
+              <a:buNone/>
+            </a:pPr>
+            <a:r>
+              <a:rPr lang="en-US" sz="1700" dirty="0">
+                <a:solidFill>
+                  <a:srgbClr val="26221D"/>
+                </a:solidFill>
+                <a:latin typeface="Geist Variable" pitchFamily="34" charset="0"/>
+                <a:ea typeface="Geist Variable" pitchFamily="34" charset="-122"/>
+                <a:cs typeface="Geist Variable" pitchFamily="34" charset="-120"/>
+              </a:rPr>
+              <a:t>02  Separate supplied evidence from open assumptions</a:t>
+            </a:r>
+            <a:endParaRPr lang="en-US" sz="1700" dirty="0"/>
+          </a:p>
+        </p:txBody>
+      </p:sp>
+      <p:sp>
+        <p:nvSpPr>
+          <p:cNvPr id="8" name="element_24d4817d32ebadb03e5b2868e34409d4"/>
+          <p:cNvSpPr txBox="1"/>
+          <p:nvPr/>
+        </p:nvSpPr>
+        <p:spPr>
+          <a:xfrm>
+            <a:off x="975336" y="5356784"/>
+            <a:ext cx="4023259" cy="518465"/>
+          </a:xfrm>
+          <a:prstGeom prst="rect">
+            <a:avLst/>
+          </a:prstGeom>
+          <a:noFill/>
+          <a:ln/>
+        </p:spPr>
+        <p:txBody>
+          <a:bodyPr wrap="square" lIns="0" tIns="0" rIns="0" bIns="0" rtlCol="0" anchor="t">
+            <a:normAutofit/>
+          </a:bodyPr>
+          <a:lstStyle/>
+          <a:p>
+            <a:pPr algn="l" indent="0" marL="0">
+              <a:lnSpc>
+                <a:spcPct val="120000"/>
+              </a:lnSpc>
+              <a:buNone/>
+            </a:pPr>
+            <a:r>
+              <a:rPr lang="en-US" sz="1700" dirty="0">
+                <a:solidFill>
+                  <a:srgbClr val="26221D"/>
+                </a:solidFill>
+                <a:latin typeface="Geist Variable" pitchFamily="34" charset="0"/>
+                <a:ea typeface="Geist Variable" pitchFamily="34" charset="-122"/>
+                <a:cs typeface="Geist Variable" pitchFamily="34" charset="-120"/>
+              </a:rPr>
+              <a:t>03  Name the decision owner and next checkpoint</a:t>
+            </a:r>
+            <a:endParaRPr lang="en-US" sz="1700" dirty="0"/>
+          </a:p>
+        </p:txBody>
+      </p:sp>
+      <p:sp>
+        <p:nvSpPr>
+          <p:cNvPr id="9" name="element_b2854094ce033f66e0f2567d3da73b0e"/>
+          <p:cNvSpPr/>
+          <p:nvPr/>
+        </p:nvSpPr>
+        <p:spPr>
+          <a:xfrm>
+            <a:off x="3177156" y="356616"/>
+            <a:ext cx="146300" cy="685800"/>
+          </a:xfrm>
+          <a:prstGeom prst="roundRect">
+            <a:avLst/>
+          </a:prstGeom>
+          <a:solidFill>
+            <a:srgbClr val="34452C"/>
+          </a:solidFill>
+          <a:ln w="12700">
+            <a:solidFill>
+              <a:srgbClr val="FFFFFF">
+                <a:alpha val="0"/>
+              </a:srgbClr>
+            </a:solidFill>
+            <a:prstDash val="solid"/>
+          </a:ln>
+        </p:spPr>
+      </p:sp>
+      <p:sp>
+        <p:nvSpPr>
+          <p:cNvPr id="10" name="element_48402ebbe3a8ec3b2a5f26360b92c1dc"/>
+          <p:cNvSpPr/>
+          <p:nvPr/>
+        </p:nvSpPr>
+        <p:spPr>
+          <a:xfrm>
+            <a:off x="1431305" y="356616"/>
+            <a:ext cx="146300" cy="685800"/>
+          </a:xfrm>
+          <a:prstGeom prst="roundRect">
+            <a:avLst/>
+          </a:prstGeom>
+          <a:solidFill>
+            <a:srgbClr val="34452C"/>
+          </a:solidFill>
+          <a:ln w="12700">
+            <a:solidFill>
+              <a:srgbClr val="FFFFFF">
+                <a:alpha val="0"/>
+              </a:srgbClr>
+            </a:solidFill>
+            <a:prstDash val="solid"/>
+          </a:ln>
+        </p:spPr>
+      </p:sp>
+      <p:sp>
+        <p:nvSpPr>
+          <p:cNvPr id="11" name="element_25e116853f5c838cfc7009e9ec971251"/>
+          <p:cNvSpPr/>
+          <p:nvPr/>
+        </p:nvSpPr>
+        <p:spPr>
+          <a:xfrm>
+            <a:off x="1576386" y="850392"/>
+            <a:ext cx="1600770" cy="68580"/>
+          </a:xfrm>
+          <a:prstGeom prst="roundRect">
+            <a:avLst/>
+          </a:prstGeom>
+          <a:solidFill>
+            <a:srgbClr val="F2DED3">
+              <a:alpha val="74000"/>
+            </a:srgbClr>
+          </a:solidFill>
+          <a:ln w="12700">
+            <a:solidFill>
+              <a:srgbClr val="FFFFFF">
+                <a:alpha val="0"/>
+              </a:srgbClr>
+            </a:solidFill>
+            <a:prstDash val="solid"/>
+          </a:ln>
+        </p:spPr>
+      </p:sp>
+      <p:sp>
+        <p:nvSpPr>
+          <p:cNvPr id="12" name="element_211bb930c058f5f9c6b025ea955129de"/>
+          <p:cNvSpPr/>
+          <p:nvPr/>
+        </p:nvSpPr>
+        <p:spPr>
+          <a:xfrm>
+            <a:off x="1460565" y="768096"/>
+            <a:ext cx="268217" cy="150876"/>
+          </a:xfrm>
+          <a:prstGeom prst="roundRect">
+            <a:avLst/>
+          </a:prstGeom>
+          <a:solidFill>
+            <a:srgbClr val="B44A2D"/>
+          </a:solidFill>
+          <a:ln w="12700">
+            <a:solidFill>
+              <a:srgbClr val="FFFFFF">
+                <a:alpha val="0"/>
+              </a:srgbClr>
+            </a:solidFill>
+            <a:prstDash val="solid"/>
+          </a:ln>
+        </p:spPr>
+      </p:sp>
+      <p:sp>
+        <p:nvSpPr>
+          <p:cNvPr id="13" name="element_d7b507fb8a349bc29e7f736b6a316300"/>
+          <p:cNvSpPr txBox="1"/>
+          <p:nvPr/>
+        </p:nvSpPr>
+        <p:spPr>
+          <a:xfrm>
+            <a:off x="2560256" y="6377940"/>
             <a:ext cx="8778021" cy="240030"/>
           </a:xfrm>
           <a:prstGeom prst="rect">
@@ -3172,13 +3234,13 @@
       </p:sp>
       <p:sp>
         <p:nvSpPr>
-          <p:cNvPr id="13" name="element_93c05a6fef75185268d70ddaaf947c84"/>
+          <p:cNvPr id="14" name="element_93c05a6fef75185268d70ddaaf947c84"/>
           <p:cNvSpPr txBox="1"/>
           <p:nvPr/>
         </p:nvSpPr>
         <p:spPr>
           <a:xfrm>
-            <a:off x="10728692" y="6309360"/>
+            <a:off x="731502" y="6309360"/>
             <a:ext cx="731502" cy="342900"/>
           </a:xfrm>
           <a:prstGeom prst="rect">
@@ -5689,14 +5751,159 @@
       </p:sp>
       <p:sp>
         <p:nvSpPr>
-          <p:cNvPr id="3" name="element_53b2a433e8ef3a6bd8d138ad80445754"/>
+          <p:cNvPr id="3" name="element_f3f59aab8c5e2645319ab05b4fa0af13"/>
+          <p:cNvSpPr/>
+          <p:nvPr/>
+        </p:nvSpPr>
+        <p:spPr>
+          <a:xfrm>
+            <a:off x="6339682" y="1920240"/>
+            <a:ext cx="5120512" cy="3017520"/>
+          </a:xfrm>
+          <a:prstGeom prst="roundRect">
+            <a:avLst/>
+          </a:prstGeom>
+          <a:solidFill>
+            <a:srgbClr val="F2DED3">
+              <a:alpha val="22000"/>
+            </a:srgbClr>
+          </a:solidFill>
+          <a:ln w="12700">
+            <a:solidFill>
+              <a:srgbClr val="FFFFFF">
+                <a:alpha val="0"/>
+              </a:srgbClr>
+            </a:solidFill>
+            <a:prstDash val="solid"/>
+          </a:ln>
+        </p:spPr>
+      </p:sp>
+      <p:sp>
+        <p:nvSpPr>
+          <p:cNvPr id="4" name="element_80139f17b05b16ea962bd6c5827bc565"/>
+          <p:cNvSpPr/>
+          <p:nvPr/>
+        </p:nvSpPr>
+        <p:spPr>
+          <a:xfrm>
+            <a:off x="8028231" y="2309774"/>
+            <a:ext cx="225546" cy="2331720"/>
+          </a:xfrm>
+          <a:prstGeom prst="roundRect">
+            <a:avLst/>
+          </a:prstGeom>
+          <a:solidFill>
+            <a:srgbClr val="34452C">
+              <a:alpha val="54000"/>
+            </a:srgbClr>
+          </a:solidFill>
+          <a:ln w="12700">
+            <a:solidFill>
+              <a:srgbClr val="FFFFFF">
+                <a:alpha val="0"/>
+              </a:srgbClr>
+            </a:solidFill>
+            <a:prstDash val="solid"/>
+          </a:ln>
+        </p:spPr>
+      </p:sp>
+      <p:sp>
+        <p:nvSpPr>
+          <p:cNvPr id="5" name="element_09429fc6a045697dc92d8b9c551a829f"/>
+          <p:cNvSpPr/>
+          <p:nvPr/>
+        </p:nvSpPr>
+        <p:spPr>
+          <a:xfrm>
+            <a:off x="9735069" y="2309774"/>
+            <a:ext cx="225546" cy="2331720"/>
+          </a:xfrm>
+          <a:prstGeom prst="roundRect">
+            <a:avLst/>
+          </a:prstGeom>
+          <a:solidFill>
+            <a:srgbClr val="34452C">
+              <a:alpha val="54000"/>
+            </a:srgbClr>
+          </a:solidFill>
+          <a:ln w="12700">
+            <a:solidFill>
+              <a:srgbClr val="FFFFFF">
+                <a:alpha val="0"/>
+              </a:srgbClr>
+            </a:solidFill>
+            <a:prstDash val="solid"/>
+          </a:ln>
+        </p:spPr>
+      </p:sp>
+      <p:sp>
+        <p:nvSpPr>
+          <p:cNvPr id="6" name="element_7cafa24ba8e6bd67c7d9638ffc439efa"/>
+          <p:cNvSpPr/>
+          <p:nvPr/>
+        </p:nvSpPr>
+        <p:spPr>
+          <a:xfrm>
+            <a:off x="8253778" y="3988613"/>
+            <a:ext cx="1481291" cy="209855"/>
+          </a:xfrm>
+          <a:prstGeom prst="roundRect">
+            <a:avLst/>
+          </a:prstGeom>
+          <a:solidFill>
+            <a:srgbClr val="F2DED3">
+              <a:alpha val="57000"/>
+            </a:srgbClr>
+          </a:solidFill>
+          <a:ln w="12700">
+            <a:solidFill>
+              <a:srgbClr val="FFFFFF">
+                <a:alpha val="0"/>
+              </a:srgbClr>
+            </a:solidFill>
+            <a:prstDash val="solid"/>
+          </a:ln>
+        </p:spPr>
+      </p:sp>
+      <p:sp>
+        <p:nvSpPr>
+          <p:cNvPr id="7" name="element_12fee635c3eb15f87ee7f7b760203956"/>
+          <p:cNvSpPr/>
+          <p:nvPr/>
+        </p:nvSpPr>
+        <p:spPr>
+          <a:xfrm>
+            <a:off x="8208668" y="3708806"/>
+            <a:ext cx="413298" cy="512978"/>
+          </a:xfrm>
+          <a:prstGeom prst="roundRect">
+            <a:avLst/>
+          </a:prstGeom>
+          <a:solidFill>
+            <a:srgbClr val="B44A2D">
+              <a:alpha val="54000"/>
+            </a:srgbClr>
+          </a:solidFill>
+          <a:ln w="12700">
+            <a:solidFill>
+              <a:srgbClr val="FFFFFF">
+                <a:alpha val="0"/>
+              </a:srgbClr>
+            </a:solidFill>
+            <a:prstDash val="solid"/>
+          </a:ln>
+        </p:spPr>
+      </p:sp>
+      <p:sp>
+        <p:nvSpPr>
+          <p:cNvPr id="8" name="element_53b2a433e8ef3a6bd8d138ad80445754"/>
           <p:cNvSpPr txBox="1"/>
           <p:nvPr/>
         </p:nvSpPr>
         <p:spPr>
           <a:xfrm>
-            <a:off x="853419" y="445770"/>
-            <a:ext cx="4876678" cy="342900"/>
+            <a:off x="731502" y="445770"/>
+            <a:ext cx="3657509" cy="342900"/>
           </a:xfrm>
           <a:prstGeom prst="rect">
             <a:avLst/>
@@ -5733,14 +5940,14 @@
       </p:sp>
       <p:sp>
         <p:nvSpPr>
-          <p:cNvPr id="4" name="element_01792f9e8d1815f7b370f8a6f9d84ffc"/>
+          <p:cNvPr id="9" name="element_01792f9e8d1815f7b370f8a6f9d84ffc"/>
           <p:cNvSpPr txBox="1"/>
           <p:nvPr/>
         </p:nvSpPr>
         <p:spPr>
           <a:xfrm>
-            <a:off x="853419" y="1028700"/>
-            <a:ext cx="9631439" cy="960120"/>
+            <a:off x="731502" y="1234440"/>
+            <a:ext cx="4876678" cy="2258339"/>
           </a:xfrm>
           <a:prstGeom prst="rect">
             <a:avLst/>
@@ -5756,12 +5963,12 @@
           <a:p>
             <a:pPr algn="l" indent="0" marL="0">
               <a:lnSpc>
-                <a:spcPct val="105000"/>
+                <a:spcPct val="104000"/>
               </a:lnSpc>
               <a:buNone/>
             </a:pPr>
             <a:r>
-              <a:rPr lang="en-US" sz="3600" b="1" spc="-40" kern="0" dirty="0">
+              <a:rPr lang="en-US" sz="3800" b="1" spc="-50" kern="0" dirty="0">
                 <a:solidFill>
                   <a:srgbClr val="26221D"/>
                 </a:solidFill>
@@ -5771,20 +5978,20 @@
               </a:rPr>
               <a:t>Define proof before asking for commitment.</a:t>
             </a:r>
-            <a:endParaRPr lang="en-US" sz="3600" dirty="0"/>
-          </a:p>
-        </p:txBody>
-      </p:sp>
-      <p:sp>
-        <p:nvSpPr>
-          <p:cNvPr id="5" name="element_44704871b8544e94d876edeb52c0099e"/>
+            <a:endParaRPr lang="en-US" sz="3800" dirty="0"/>
+          </a:p>
+        </p:txBody>
+      </p:sp>
+      <p:sp>
+        <p:nvSpPr>
+          <p:cNvPr id="10" name="element_aa94a395efe36a9ee0b532c5acb6bfae"/>
           <p:cNvSpPr txBox="1"/>
           <p:nvPr/>
         </p:nvSpPr>
         <p:spPr>
           <a:xfrm>
-            <a:off x="853419" y="2400300"/>
-            <a:ext cx="3251525" cy="548640"/>
+            <a:off x="731502" y="3732809"/>
+            <a:ext cx="4876678" cy="1410691"/>
           </a:xfrm>
           <a:prstGeom prst="rect">
             <a:avLst/>
@@ -5800,35 +6007,35 @@
           <a:p>
             <a:pPr algn="l" indent="0" marL="0">
               <a:lnSpc>
-                <a:spcPct val="120000"/>
+                <a:spcPct val="138000"/>
               </a:lnSpc>
               <a:buNone/>
             </a:pPr>
             <a:r>
-              <a:rPr lang="en-US" sz="2200" b="1" dirty="0">
+              <a:rPr lang="en-US" sz="1600" dirty="0">
                 <a:solidFill>
-                  <a:srgbClr val="B44A2D"/>
+                  <a:srgbClr val="756B61"/>
                 </a:solidFill>
-                <a:latin typeface="JetBrains Mono Variable" pitchFamily="34" charset="0"/>
-                <a:ea typeface="JetBrains Mono Variable" pitchFamily="34" charset="-122"/>
-                <a:cs typeface="JetBrains Mono Variable" pitchFamily="34" charset="-120"/>
+                <a:latin typeface="Geist Variable" pitchFamily="34" charset="0"/>
+                <a:ea typeface="Geist Variable" pitchFamily="34" charset="-122"/>
+                <a:cs typeface="Geist Variable" pitchFamily="34" charset="-120"/>
               </a:rPr>
-              <a:t>01</a:t>
-            </a:r>
-            <a:endParaRPr lang="en-US" sz="2200" dirty="0"/>
-          </a:p>
-        </p:txBody>
-      </p:sp>
-      <p:sp>
-        <p:nvSpPr>
-          <p:cNvPr id="6" name="element_2157ef83b010916f9b5dbcef830294ea"/>
+              <a:t>Use the brief’s success criteria as qualitative review questions until measured evidence is supplied.</a:t>
+            </a:r>
+            <a:endParaRPr lang="en-US" sz="1600" dirty="0"/>
+          </a:p>
+        </p:txBody>
+      </p:sp>
+      <p:sp>
+        <p:nvSpPr>
+          <p:cNvPr id="11" name="element_a78d40d8d28a9e2aaad0662cd5c02e6e"/>
           <p:cNvSpPr txBox="1"/>
           <p:nvPr/>
         </p:nvSpPr>
         <p:spPr>
           <a:xfrm>
-            <a:off x="853419" y="2948940"/>
-            <a:ext cx="3251525" cy="2331720"/>
+            <a:off x="731502" y="5280660"/>
+            <a:ext cx="4876678" cy="754380"/>
           </a:xfrm>
           <a:prstGeom prst="rect">
             <a:avLst/>
@@ -5837,21 +6044,21 @@
           <a:ln/>
         </p:spPr>
         <p:txBody>
-          <a:bodyPr wrap="square" lIns="0" tIns="0" rIns="0" bIns="0" rtlCol="0" anchor="t">
+          <a:bodyPr wrap="square" lIns="152400" tIns="152400" rIns="152400" bIns="152400" rtlCol="0" anchor="t">
             <a:normAutofit/>
           </a:bodyPr>
           <a:lstStyle/>
           <a:p>
             <a:pPr algn="l" indent="0" marL="0">
               <a:lnSpc>
-                <a:spcPct val="130000"/>
+                <a:spcPct val="125000"/>
               </a:lnSpc>
               <a:buNone/>
             </a:pPr>
             <a:r>
-              <a:rPr lang="en-US" sz="1700" dirty="0">
+              <a:rPr lang="en-US" sz="1600" b="1" dirty="0">
                 <a:solidFill>
-                  <a:srgbClr val="26221D"/>
+                  <a:srgbClr val="34452C"/>
                 </a:solidFill>
                 <a:latin typeface="Geist Variable" pitchFamily="34" charset="0"/>
                 <a:ea typeface="Geist Variable" pitchFamily="34" charset="-122"/>
@@ -5859,359 +6066,13 @@
               </a:rPr>
               <a:t>Preserve all twelve narrative jobs</a:t>
             </a:r>
-            <a:endParaRPr lang="en-US" sz="1700" dirty="0"/>
-          </a:p>
-        </p:txBody>
-      </p:sp>
-      <p:sp>
-        <p:nvSpPr>
-          <p:cNvPr id="7" name="element_8d5ff8f0f31852747fc6800e4b15997e"/>
-          <p:cNvSpPr/>
-          <p:nvPr/>
-        </p:nvSpPr>
-        <p:spPr>
-          <a:xfrm>
-            <a:off x="4287819" y="2400300"/>
-            <a:ext cx="121917" cy="2880360"/>
-          </a:xfrm>
-          <a:prstGeom prst="rect">
-            <a:avLst/>
-          </a:prstGeom>
-          <a:solidFill>
-            <a:srgbClr val="DED7CC"/>
-          </a:solidFill>
-          <a:ln w="12700">
-            <a:solidFill>
-              <a:srgbClr val="FFFFFF">
-                <a:alpha val="0"/>
-              </a:srgbClr>
-            </a:solidFill>
-            <a:prstDash val="solid"/>
-          </a:ln>
-        </p:spPr>
-      </p:sp>
-      <p:sp>
-        <p:nvSpPr>
-          <p:cNvPr id="8" name="element_9928458764e9ba4338e7aedbaa47f52b"/>
-          <p:cNvSpPr txBox="1"/>
-          <p:nvPr/>
-        </p:nvSpPr>
-        <p:spPr>
-          <a:xfrm>
-            <a:off x="4470695" y="2400300"/>
-            <a:ext cx="3251525" cy="548640"/>
-          </a:xfrm>
-          <a:prstGeom prst="rect">
-            <a:avLst/>
-          </a:prstGeom>
-          <a:noFill/>
-          <a:ln/>
-        </p:spPr>
-        <p:txBody>
-          <a:bodyPr wrap="square" lIns="0" tIns="0" rIns="0" bIns="0" rtlCol="0" anchor="t">
-            <a:normAutofit/>
-          </a:bodyPr>
-          <a:lstStyle/>
-          <a:p>
-            <a:pPr algn="l" indent="0" marL="0">
-              <a:lnSpc>
-                <a:spcPct val="120000"/>
-              </a:lnSpc>
-              <a:buNone/>
-            </a:pPr>
-            <a:r>
-              <a:rPr lang="en-US" sz="2200" b="1" dirty="0">
-                <a:solidFill>
-                  <a:srgbClr val="B44A2D"/>
-                </a:solidFill>
-                <a:latin typeface="JetBrains Mono Variable" pitchFamily="34" charset="0"/>
-                <a:ea typeface="JetBrains Mono Variable" pitchFamily="34" charset="-122"/>
-                <a:cs typeface="JetBrains Mono Variable" pitchFamily="34" charset="-120"/>
-              </a:rPr>
-              <a:t>02</a:t>
-            </a:r>
-            <a:endParaRPr lang="en-US" sz="2200" dirty="0"/>
-          </a:p>
-        </p:txBody>
-      </p:sp>
-      <p:sp>
-        <p:nvSpPr>
-          <p:cNvPr id="9" name="element_25ab8a0b9a34b1d2eda8d1deb1cb4ff5"/>
-          <p:cNvSpPr txBox="1"/>
-          <p:nvPr/>
-        </p:nvSpPr>
-        <p:spPr>
-          <a:xfrm>
-            <a:off x="4470695" y="2948940"/>
-            <a:ext cx="3251525" cy="2331720"/>
-          </a:xfrm>
-          <a:prstGeom prst="rect">
-            <a:avLst/>
-          </a:prstGeom>
-          <a:noFill/>
-          <a:ln/>
-        </p:spPr>
-        <p:txBody>
-          <a:bodyPr wrap="square" lIns="0" tIns="0" rIns="0" bIns="0" rtlCol="0" anchor="t">
-            <a:normAutofit/>
-          </a:bodyPr>
-          <a:lstStyle/>
-          <a:p>
-            <a:pPr algn="l" indent="0" marL="0">
-              <a:lnSpc>
-                <a:spcPct val="130000"/>
-              </a:lnSpc>
-              <a:buNone/>
-            </a:pPr>
-            <a:r>
-              <a:rPr lang="en-US" sz="1700" dirty="0">
-                <a:solidFill>
-                  <a:srgbClr val="26221D"/>
-                </a:solidFill>
-                <a:latin typeface="Geist Variable" pitchFamily="34" charset="0"/>
-                <a:ea typeface="Geist Variable" pitchFamily="34" charset="-122"/>
-                <a:cs typeface="Geist Variable" pitchFamily="34" charset="-120"/>
-              </a:rPr>
-              <a:t>Separate supplied evidence from open assumptions</a:t>
-            </a:r>
-            <a:endParaRPr lang="en-US" sz="1700" dirty="0"/>
-          </a:p>
-        </p:txBody>
-      </p:sp>
-      <p:sp>
-        <p:nvSpPr>
-          <p:cNvPr id="10" name="element_7cd7907b726a03416569533f84e11da8"/>
-          <p:cNvSpPr/>
-          <p:nvPr/>
-        </p:nvSpPr>
-        <p:spPr>
-          <a:xfrm>
-            <a:off x="7903876" y="2400300"/>
-            <a:ext cx="121917" cy="2880360"/>
-          </a:xfrm>
-          <a:prstGeom prst="rect">
-            <a:avLst/>
-          </a:prstGeom>
-          <a:solidFill>
-            <a:srgbClr val="DED7CC"/>
-          </a:solidFill>
-          <a:ln w="12700">
-            <a:solidFill>
-              <a:srgbClr val="FFFFFF">
-                <a:alpha val="0"/>
-              </a:srgbClr>
-            </a:solidFill>
-            <a:prstDash val="solid"/>
-          </a:ln>
-        </p:spPr>
-      </p:sp>
-      <p:sp>
-        <p:nvSpPr>
-          <p:cNvPr id="11" name="element_e4ca20bb102ca03a4fd883346de8f290"/>
-          <p:cNvSpPr txBox="1"/>
-          <p:nvPr/>
-        </p:nvSpPr>
-        <p:spPr>
-          <a:xfrm>
-            <a:off x="8086751" y="2400300"/>
-            <a:ext cx="3251525" cy="548640"/>
-          </a:xfrm>
-          <a:prstGeom prst="rect">
-            <a:avLst/>
-          </a:prstGeom>
-          <a:noFill/>
-          <a:ln/>
-        </p:spPr>
-        <p:txBody>
-          <a:bodyPr wrap="square" lIns="0" tIns="0" rIns="0" bIns="0" rtlCol="0" anchor="t">
-            <a:normAutofit/>
-          </a:bodyPr>
-          <a:lstStyle/>
-          <a:p>
-            <a:pPr algn="l" indent="0" marL="0">
-              <a:lnSpc>
-                <a:spcPct val="120000"/>
-              </a:lnSpc>
-              <a:buNone/>
-            </a:pPr>
-            <a:r>
-              <a:rPr lang="en-US" sz="2200" b="1" dirty="0">
-                <a:solidFill>
-                  <a:srgbClr val="B44A2D"/>
-                </a:solidFill>
-                <a:latin typeface="JetBrains Mono Variable" pitchFamily="34" charset="0"/>
-                <a:ea typeface="JetBrains Mono Variable" pitchFamily="34" charset="-122"/>
-                <a:cs typeface="JetBrains Mono Variable" pitchFamily="34" charset="-120"/>
-              </a:rPr>
-              <a:t>03</a:t>
-            </a:r>
-            <a:endParaRPr lang="en-US" sz="2200" dirty="0"/>
-          </a:p>
-        </p:txBody>
-      </p:sp>
-      <p:sp>
-        <p:nvSpPr>
-          <p:cNvPr id="12" name="element_9813dc6398ddba5956c8f55d433b1bf1"/>
-          <p:cNvSpPr txBox="1"/>
-          <p:nvPr/>
-        </p:nvSpPr>
-        <p:spPr>
-          <a:xfrm>
-            <a:off x="8086751" y="2948940"/>
-            <a:ext cx="3251525" cy="2331720"/>
-          </a:xfrm>
-          <a:prstGeom prst="rect">
-            <a:avLst/>
-          </a:prstGeom>
-          <a:noFill/>
-          <a:ln/>
-        </p:spPr>
-        <p:txBody>
-          <a:bodyPr wrap="square" lIns="0" tIns="0" rIns="0" bIns="0" rtlCol="0" anchor="t">
-            <a:normAutofit/>
-          </a:bodyPr>
-          <a:lstStyle/>
-          <a:p>
-            <a:pPr algn="l" indent="0" marL="0">
-              <a:lnSpc>
-                <a:spcPct val="130000"/>
-              </a:lnSpc>
-              <a:buNone/>
-            </a:pPr>
-            <a:r>
-              <a:rPr lang="en-US" sz="1700" dirty="0">
-                <a:solidFill>
-                  <a:srgbClr val="26221D"/>
-                </a:solidFill>
-                <a:latin typeface="Geist Variable" pitchFamily="34" charset="0"/>
-                <a:ea typeface="Geist Variable" pitchFamily="34" charset="-122"/>
-                <a:cs typeface="Geist Variable" pitchFamily="34" charset="-120"/>
-              </a:rPr>
-              <a:t>Name the decision owner and next checkpoint</a:t>
-            </a:r>
-            <a:endParaRPr lang="en-US" sz="1700" dirty="0"/>
-          </a:p>
-        </p:txBody>
-      </p:sp>
-      <p:sp>
-        <p:nvSpPr>
-          <p:cNvPr id="13" name="element_80139f17b05b16ea962bd6c5827bc565"/>
-          <p:cNvSpPr/>
-          <p:nvPr/>
-        </p:nvSpPr>
-        <p:spPr>
-          <a:xfrm>
-            <a:off x="9187662" y="356616"/>
-            <a:ext cx="146300" cy="685800"/>
-          </a:xfrm>
-          <a:prstGeom prst="roundRect">
-            <a:avLst/>
-          </a:prstGeom>
-          <a:solidFill>
-            <a:srgbClr val="34452C">
-              <a:alpha val="54000"/>
-            </a:srgbClr>
-          </a:solidFill>
-          <a:ln w="12700">
-            <a:solidFill>
-              <a:srgbClr val="FFFFFF">
-                <a:alpha val="0"/>
-              </a:srgbClr>
-            </a:solidFill>
-            <a:prstDash val="solid"/>
-          </a:ln>
-        </p:spPr>
-      </p:sp>
-      <p:sp>
-        <p:nvSpPr>
-          <p:cNvPr id="14" name="element_09429fc6a045697dc92d8b9c551a829f"/>
-          <p:cNvSpPr/>
-          <p:nvPr/>
-        </p:nvSpPr>
-        <p:spPr>
-          <a:xfrm>
-            <a:off x="10294667" y="356616"/>
-            <a:ext cx="146300" cy="685800"/>
-          </a:xfrm>
-          <a:prstGeom prst="roundRect">
-            <a:avLst/>
-          </a:prstGeom>
-          <a:solidFill>
-            <a:srgbClr val="34452C">
-              <a:alpha val="54000"/>
-            </a:srgbClr>
-          </a:solidFill>
-          <a:ln w="12700">
-            <a:solidFill>
-              <a:srgbClr val="FFFFFF">
-                <a:alpha val="0"/>
-              </a:srgbClr>
-            </a:solidFill>
-            <a:prstDash val="solid"/>
-          </a:ln>
-        </p:spPr>
-      </p:sp>
-      <p:sp>
-        <p:nvSpPr>
-          <p:cNvPr id="15" name="element_7cafa24ba8e6bd67c7d9638ffc439efa"/>
-          <p:cNvSpPr/>
-          <p:nvPr/>
-        </p:nvSpPr>
-        <p:spPr>
-          <a:xfrm>
-            <a:off x="9333962" y="850392"/>
-            <a:ext cx="960706" cy="68580"/>
-          </a:xfrm>
-          <a:prstGeom prst="roundRect">
-            <a:avLst/>
-          </a:prstGeom>
-          <a:solidFill>
-            <a:srgbClr val="F2DED3">
-              <a:alpha val="57000"/>
-            </a:srgbClr>
-          </a:solidFill>
-          <a:ln w="12700">
-            <a:solidFill>
-              <a:srgbClr val="FFFFFF">
-                <a:alpha val="0"/>
-              </a:srgbClr>
-            </a:solidFill>
-            <a:prstDash val="solid"/>
-          </a:ln>
-        </p:spPr>
-      </p:sp>
-      <p:sp>
-        <p:nvSpPr>
-          <p:cNvPr id="16" name="element_12fee635c3eb15f87ee7f7b760203956"/>
-          <p:cNvSpPr/>
-          <p:nvPr/>
-        </p:nvSpPr>
-        <p:spPr>
-          <a:xfrm>
-            <a:off x="9304702" y="768096"/>
-            <a:ext cx="268217" cy="150876"/>
-          </a:xfrm>
-          <a:prstGeom prst="roundRect">
-            <a:avLst/>
-          </a:prstGeom>
-          <a:solidFill>
-            <a:srgbClr val="B44A2D">
-              <a:alpha val="54000"/>
-            </a:srgbClr>
-          </a:solidFill>
-          <a:ln w="12700">
-            <a:solidFill>
-              <a:srgbClr val="FFFFFF">
-                <a:alpha val="0"/>
-              </a:srgbClr>
-            </a:solidFill>
-            <a:prstDash val="solid"/>
-          </a:ln>
-        </p:spPr>
-      </p:sp>
-      <p:sp>
-        <p:nvSpPr>
-          <p:cNvPr id="17" name="element_9172bfd2dfe4f2b6ae93e28ac873fb18"/>
+            <a:endParaRPr lang="en-US" sz="1600" dirty="0"/>
+          </a:p>
+        </p:txBody>
+      </p:sp>
+      <p:sp>
+        <p:nvSpPr>
+          <p:cNvPr id="12" name="element_9172bfd2dfe4f2b6ae93e28ac873fb18"/>
           <p:cNvSpPr txBox="1"/>
           <p:nvPr/>
         </p:nvSpPr>
@@ -6255,7 +6116,7 @@
       </p:sp>
       <p:sp>
         <p:nvSpPr>
-          <p:cNvPr id="18" name="element_8bdb2720aa1fb4821ec84908bcdb4525"/>
+          <p:cNvPr id="13" name="element_8bdb2720aa1fb4821ec84908bcdb4525"/>
           <p:cNvSpPr txBox="1"/>
           <p:nvPr/>
         </p:nvSpPr>
@@ -6360,14 +6221,159 @@
       </p:sp>
       <p:sp>
         <p:nvSpPr>
-          <p:cNvPr id="3" name="element_70b5d3f8eb26779c32227b9d7aded23e"/>
+          <p:cNvPr id="3" name="element_b83557236440b86c319a667f95d4d550"/>
+          <p:cNvSpPr/>
+          <p:nvPr/>
+        </p:nvSpPr>
+        <p:spPr>
+          <a:xfrm>
+            <a:off x="3291758" y="960120"/>
+            <a:ext cx="5608180" cy="2331720"/>
+          </a:xfrm>
+          <a:prstGeom prst="roundRect">
+            <a:avLst/>
+          </a:prstGeom>
+          <a:solidFill>
+            <a:srgbClr val="F2DED3">
+              <a:alpha val="22000"/>
+            </a:srgbClr>
+          </a:solidFill>
+          <a:ln w="12700">
+            <a:solidFill>
+              <a:srgbClr val="FFFFFF">
+                <a:alpha val="0"/>
+              </a:srgbClr>
+            </a:solidFill>
+            <a:prstDash val="solid"/>
+          </a:ln>
+        </p:spPr>
+      </p:sp>
+      <p:sp>
+        <p:nvSpPr>
+          <p:cNvPr id="4" name="element_b846cd9bc4eb2f58ac9758e24f46d1d2"/>
+          <p:cNvSpPr/>
+          <p:nvPr/>
+        </p:nvSpPr>
+        <p:spPr>
+          <a:xfrm>
+            <a:off x="6901719" y="1335938"/>
+            <a:ext cx="249930" cy="1645920"/>
+          </a:xfrm>
+          <a:prstGeom prst="roundRect">
+            <a:avLst/>
+          </a:prstGeom>
+          <a:solidFill>
+            <a:srgbClr val="34452C">
+              <a:alpha val="62000"/>
+            </a:srgbClr>
+          </a:solidFill>
+          <a:ln w="12700">
+            <a:solidFill>
+              <a:srgbClr val="FFFFFF">
+                <a:alpha val="0"/>
+              </a:srgbClr>
+            </a:solidFill>
+            <a:prstDash val="solid"/>
+          </a:ln>
+        </p:spPr>
+      </p:sp>
+      <p:sp>
+        <p:nvSpPr>
+          <p:cNvPr id="5" name="element_746ebbf3c45d87c1c2255623c24d229b"/>
+          <p:cNvSpPr/>
+          <p:nvPr/>
+        </p:nvSpPr>
+        <p:spPr>
+          <a:xfrm>
+            <a:off x="4829130" y="1335938"/>
+            <a:ext cx="249930" cy="1645920"/>
+          </a:xfrm>
+          <a:prstGeom prst="roundRect">
+            <a:avLst/>
+          </a:prstGeom>
+          <a:solidFill>
+            <a:srgbClr val="34452C">
+              <a:alpha val="62000"/>
+            </a:srgbClr>
+          </a:solidFill>
+          <a:ln w="12700">
+            <a:solidFill>
+              <a:srgbClr val="FFFFFF">
+                <a:alpha val="0"/>
+              </a:srgbClr>
+            </a:solidFill>
+            <a:prstDash val="solid"/>
+          </a:ln>
+        </p:spPr>
+      </p:sp>
+      <p:sp>
+        <p:nvSpPr>
+          <p:cNvPr id="6" name="element_d9a09c6cc4c7c4d4ca167af50ec5cf32"/>
+          <p:cNvSpPr/>
+          <p:nvPr/>
+        </p:nvSpPr>
+        <p:spPr>
+          <a:xfrm>
+            <a:off x="5079060" y="2521001"/>
+            <a:ext cx="1822658" cy="148133"/>
+          </a:xfrm>
+          <a:prstGeom prst="roundRect">
+            <a:avLst/>
+          </a:prstGeom>
+          <a:solidFill>
+            <a:srgbClr val="F2DED3">
+              <a:alpha val="59000"/>
+            </a:srgbClr>
+          </a:solidFill>
+          <a:ln w="12700">
+            <a:solidFill>
+              <a:srgbClr val="FFFFFF">
+                <a:alpha val="0"/>
+              </a:srgbClr>
+            </a:solidFill>
+            <a:prstDash val="solid"/>
+          </a:ln>
+        </p:spPr>
+      </p:sp>
+      <p:sp>
+        <p:nvSpPr>
+          <p:cNvPr id="7" name="element_506bc6b4f43e39e2e0527aa9d15bb098"/>
+          <p:cNvSpPr/>
+          <p:nvPr/>
+        </p:nvSpPr>
+        <p:spPr>
+          <a:xfrm>
+            <a:off x="6075122" y="2323490"/>
+            <a:ext cx="458408" cy="362102"/>
+          </a:xfrm>
+          <a:prstGeom prst="roundRect">
+            <a:avLst/>
+          </a:prstGeom>
+          <a:solidFill>
+            <a:srgbClr val="B44A2D">
+              <a:alpha val="62000"/>
+            </a:srgbClr>
+          </a:solidFill>
+          <a:ln w="12700">
+            <a:solidFill>
+              <a:srgbClr val="FFFFFF">
+                <a:alpha val="0"/>
+              </a:srgbClr>
+            </a:solidFill>
+            <a:prstDash val="solid"/>
+          </a:ln>
+        </p:spPr>
+      </p:sp>
+      <p:sp>
+        <p:nvSpPr>
+          <p:cNvPr id="8" name="element_70b5d3f8eb26779c32227b9d7aded23e"/>
           <p:cNvSpPr txBox="1"/>
           <p:nvPr/>
         </p:nvSpPr>
         <p:spPr>
           <a:xfrm>
-            <a:off x="6461598" y="445770"/>
-            <a:ext cx="4876678" cy="342900"/>
+            <a:off x="7680768" y="445770"/>
+            <a:ext cx="3657509" cy="342900"/>
           </a:xfrm>
           <a:prstGeom prst="rect">
             <a:avLst/>
@@ -6404,14 +6410,14 @@
       </p:sp>
       <p:sp>
         <p:nvSpPr>
-          <p:cNvPr id="4" name="element_8b5e2469f99a96aa74968ebefc93e596"/>
+          <p:cNvPr id="9" name="element_8b5e2469f99a96aa74968ebefc93e596"/>
           <p:cNvSpPr txBox="1"/>
           <p:nvPr/>
         </p:nvSpPr>
         <p:spPr>
           <a:xfrm>
-            <a:off x="853419" y="1097280"/>
-            <a:ext cx="10484858" cy="1234440"/>
+            <a:off x="5242429" y="3909060"/>
+            <a:ext cx="6095848" cy="1577340"/>
           </a:xfrm>
           <a:prstGeom prst="rect">
             <a:avLst/>
@@ -6427,12 +6433,12 @@
           <a:p>
             <a:pPr algn="l" indent="0" marL="0">
               <a:lnSpc>
-                <a:spcPct val="105000"/>
+                <a:spcPct val="104000"/>
               </a:lnSpc>
               <a:buNone/>
             </a:pPr>
             <a:r>
-              <a:rPr lang="en-US" sz="4200" b="1" spc="-60" kern="0" dirty="0">
+              <a:rPr lang="en-US" sz="3400" b="1" spc="-50" kern="0" dirty="0">
                 <a:solidFill>
                   <a:srgbClr val="26221D"/>
                 </a:solidFill>
@@ -6442,20 +6448,20 @@
               </a:rPr>
               <a:t>Start narrow, learn quickly, and preserve room to adapt.</a:t>
             </a:r>
-            <a:endParaRPr lang="en-US" sz="4200" dirty="0"/>
-          </a:p>
-        </p:txBody>
-      </p:sp>
-      <p:sp>
-        <p:nvSpPr>
-          <p:cNvPr id="5" name="element_90b730a1b2c98c39b548c807eb9b5909"/>
+            <a:endParaRPr lang="en-US" sz="3400" dirty="0"/>
+          </a:p>
+        </p:txBody>
+      </p:sp>
+      <p:sp>
+        <p:nvSpPr>
+          <p:cNvPr id="10" name="element_90b730a1b2c98c39b548c807eb9b5909"/>
           <p:cNvSpPr txBox="1"/>
           <p:nvPr/>
         </p:nvSpPr>
         <p:spPr>
           <a:xfrm>
-            <a:off x="1706837" y="2743200"/>
-            <a:ext cx="9631439" cy="1028700"/>
+            <a:off x="853419" y="4046220"/>
+            <a:ext cx="3779426" cy="1097280"/>
           </a:xfrm>
           <a:prstGeom prst="rect">
             <a:avLst/>
@@ -6471,12 +6477,12 @@
           <a:p>
             <a:pPr algn="l" indent="0" marL="0">
               <a:lnSpc>
-                <a:spcPct val="135000"/>
+                <a:spcPct val="138000"/>
               </a:lnSpc>
               <a:buNone/>
             </a:pPr>
             <a:r>
-              <a:rPr lang="en-US" sz="1800" dirty="0">
+              <a:rPr lang="en-US" sz="1500" dirty="0">
                 <a:solidFill>
                   <a:srgbClr val="756B61"/>
                 </a:solidFill>
@@ -6486,20 +6492,20 @@
               </a:rPr>
               <a:t>Sequence the work into a focused launch, an evidence review, and a deliberate scale decision with named ownership at every step.</a:t>
             </a:r>
-            <a:endParaRPr lang="en-US" sz="1800" dirty="0"/>
-          </a:p>
-        </p:txBody>
-      </p:sp>
-      <p:sp>
-        <p:nvSpPr>
-          <p:cNvPr id="6" name="element_8ee0aa206c1a25b5c9fe0405fe23f998"/>
+            <a:endParaRPr lang="en-US" sz="1500" dirty="0"/>
+          </a:p>
+        </p:txBody>
+      </p:sp>
+      <p:sp>
+        <p:nvSpPr>
+          <p:cNvPr id="11" name="element_9349235da7a1a3642195eb55f26192c5"/>
           <p:cNvSpPr txBox="1"/>
           <p:nvPr/>
         </p:nvSpPr>
         <p:spPr>
           <a:xfrm>
-            <a:off x="975336" y="3909060"/>
-            <a:ext cx="4023259" cy="518465"/>
+            <a:off x="853419" y="5280660"/>
+            <a:ext cx="3779426" cy="754380"/>
           </a:xfrm>
           <a:prstGeom prst="rect">
             <a:avLst/>
@@ -6508,239 +6514,35 @@
           <a:ln/>
         </p:spPr>
         <p:txBody>
-          <a:bodyPr wrap="square" lIns="0" tIns="0" rIns="0" bIns="0" rtlCol="0" anchor="t">
+          <a:bodyPr wrap="square" lIns="152400" tIns="152400" rIns="152400" bIns="152400" rtlCol="0" anchor="t">
             <a:normAutofit/>
           </a:bodyPr>
           <a:lstStyle/>
           <a:p>
             <a:pPr algn="l" indent="0" marL="0">
               <a:lnSpc>
-                <a:spcPct val="120000"/>
+                <a:spcPct val="125000"/>
               </a:lnSpc>
               <a:buNone/>
             </a:pPr>
             <a:r>
-              <a:rPr lang="en-US" sz="1700" dirty="0">
+              <a:rPr lang="en-US" sz="1400" b="1" dirty="0">
                 <a:solidFill>
-                  <a:srgbClr val="26221D"/>
+                  <a:srgbClr val="34452C"/>
                 </a:solidFill>
                 <a:latin typeface="Geist Variable" pitchFamily="34" charset="0"/>
                 <a:ea typeface="Geist Variable" pitchFamily="34" charset="-122"/>
                 <a:cs typeface="Geist Variable" pitchFamily="34" charset="-120"/>
               </a:rPr>
-              <a:t>01  Launch the smallest credible move</a:t>
-            </a:r>
-            <a:endParaRPr lang="en-US" sz="1700" dirty="0"/>
-          </a:p>
-        </p:txBody>
-      </p:sp>
-      <p:sp>
-        <p:nvSpPr>
-          <p:cNvPr id="7" name="element_a0b2bd1223cc79d63c445933bf2cc541"/>
-          <p:cNvSpPr txBox="1"/>
-          <p:nvPr/>
-        </p:nvSpPr>
-        <p:spPr>
-          <a:xfrm>
-            <a:off x="975336" y="4633265"/>
-            <a:ext cx="4023259" cy="518465"/>
-          </a:xfrm>
-          <a:prstGeom prst="rect">
-            <a:avLst/>
-          </a:prstGeom>
-          <a:noFill/>
-          <a:ln/>
-        </p:spPr>
-        <p:txBody>
-          <a:bodyPr wrap="square" lIns="0" tIns="0" rIns="0" bIns="0" rtlCol="0" anchor="t">
-            <a:normAutofit/>
-          </a:bodyPr>
-          <a:lstStyle/>
-          <a:p>
-            <a:pPr algn="l" indent="0" marL="0">
-              <a:lnSpc>
-                <a:spcPct val="120000"/>
-              </a:lnSpc>
-              <a:buNone/>
-            </a:pPr>
-            <a:r>
-              <a:rPr lang="en-US" sz="1700" dirty="0">
-                <a:solidFill>
-                  <a:srgbClr val="26221D"/>
-                </a:solidFill>
-                <a:latin typeface="Geist Variable" pitchFamily="34" charset="0"/>
-                <a:ea typeface="Geist Variable" pitchFamily="34" charset="-122"/>
-                <a:cs typeface="Geist Variable" pitchFamily="34" charset="-120"/>
-              </a:rPr>
-              <a:t>02  Review evidence with stakeholders</a:t>
-            </a:r>
-            <a:endParaRPr lang="en-US" sz="1700" dirty="0"/>
-          </a:p>
-        </p:txBody>
-      </p:sp>
-      <p:sp>
-        <p:nvSpPr>
-          <p:cNvPr id="8" name="element_8ed4c22901dde4e39bc7df1eb3e25f7a"/>
-          <p:cNvSpPr txBox="1"/>
-          <p:nvPr/>
-        </p:nvSpPr>
-        <p:spPr>
-          <a:xfrm>
-            <a:off x="975336" y="5356784"/>
-            <a:ext cx="4023259" cy="259232"/>
-          </a:xfrm>
-          <a:prstGeom prst="rect">
-            <a:avLst/>
-          </a:prstGeom>
-          <a:noFill/>
-          <a:ln/>
-        </p:spPr>
-        <p:txBody>
-          <a:bodyPr wrap="square" lIns="0" tIns="0" rIns="0" bIns="0" rtlCol="0" anchor="t">
-            <a:normAutofit/>
-          </a:bodyPr>
-          <a:lstStyle/>
-          <a:p>
-            <a:pPr algn="l" indent="0" marL="0">
-              <a:lnSpc>
-                <a:spcPct val="120000"/>
-              </a:lnSpc>
-              <a:buNone/>
-            </a:pPr>
-            <a:r>
-              <a:rPr lang="en-US" sz="1700" dirty="0">
-                <a:solidFill>
-                  <a:srgbClr val="26221D"/>
-                </a:solidFill>
-                <a:latin typeface="Geist Variable" pitchFamily="34" charset="0"/>
-                <a:ea typeface="Geist Variable" pitchFamily="34" charset="-122"/>
-                <a:cs typeface="Geist Variable" pitchFamily="34" charset="-120"/>
-              </a:rPr>
-              <a:t>03  Scale what earns confidence</a:t>
-            </a:r>
-            <a:endParaRPr lang="en-US" sz="1700" dirty="0"/>
-          </a:p>
-        </p:txBody>
-      </p:sp>
-      <p:sp>
-        <p:nvSpPr>
-          <p:cNvPr id="9" name="element_b846cd9bc4eb2f58ac9758e24f46d1d2"/>
-          <p:cNvSpPr/>
-          <p:nvPr/>
-        </p:nvSpPr>
-        <p:spPr>
-          <a:xfrm>
-            <a:off x="2910158" y="356616"/>
-            <a:ext cx="146300" cy="685800"/>
-          </a:xfrm>
-          <a:prstGeom prst="roundRect">
-            <a:avLst/>
-          </a:prstGeom>
-          <a:solidFill>
-            <a:srgbClr val="34452C">
-              <a:alpha val="62000"/>
-            </a:srgbClr>
-          </a:solidFill>
-          <a:ln w="12700">
-            <a:solidFill>
-              <a:srgbClr val="FFFFFF">
-                <a:alpha val="0"/>
-              </a:srgbClr>
-            </a:solidFill>
-            <a:prstDash val="solid"/>
-          </a:ln>
-        </p:spPr>
-      </p:sp>
-      <p:sp>
-        <p:nvSpPr>
-          <p:cNvPr id="10" name="element_746ebbf3c45d87c1c2255623c24d229b"/>
-          <p:cNvSpPr/>
-          <p:nvPr/>
-        </p:nvSpPr>
-        <p:spPr>
-          <a:xfrm>
-            <a:off x="1697084" y="356616"/>
-            <a:ext cx="146300" cy="685800"/>
-          </a:xfrm>
-          <a:prstGeom prst="roundRect">
-            <a:avLst/>
-          </a:prstGeom>
-          <a:solidFill>
-            <a:srgbClr val="34452C">
-              <a:alpha val="62000"/>
-            </a:srgbClr>
-          </a:solidFill>
-          <a:ln w="12700">
-            <a:solidFill>
-              <a:srgbClr val="FFFFFF">
-                <a:alpha val="0"/>
-              </a:srgbClr>
-            </a:solidFill>
-            <a:prstDash val="solid"/>
-          </a:ln>
-        </p:spPr>
-      </p:sp>
-      <p:sp>
-        <p:nvSpPr>
-          <p:cNvPr id="11" name="element_d9a09c6cc4c7c4d4ca167af50ec5cf32"/>
-          <p:cNvSpPr/>
-          <p:nvPr/>
-        </p:nvSpPr>
-        <p:spPr>
-          <a:xfrm>
-            <a:off x="1843384" y="850392"/>
-            <a:ext cx="1066773" cy="68580"/>
-          </a:xfrm>
-          <a:prstGeom prst="roundRect">
-            <a:avLst/>
-          </a:prstGeom>
-          <a:solidFill>
-            <a:srgbClr val="F2DED3">
-              <a:alpha val="59000"/>
-            </a:srgbClr>
-          </a:solidFill>
-          <a:ln w="12700">
-            <a:solidFill>
-              <a:srgbClr val="FFFFFF">
-                <a:alpha val="0"/>
-              </a:srgbClr>
-            </a:solidFill>
-            <a:prstDash val="solid"/>
-          </a:ln>
-        </p:spPr>
-      </p:sp>
-      <p:sp>
-        <p:nvSpPr>
-          <p:cNvPr id="12" name="element_506bc6b4f43e39e2e0527aa9d15bb098"/>
-          <p:cNvSpPr/>
-          <p:nvPr/>
-        </p:nvSpPr>
-        <p:spPr>
-          <a:xfrm>
-            <a:off x="2426147" y="768096"/>
-            <a:ext cx="268217" cy="150876"/>
-          </a:xfrm>
-          <a:prstGeom prst="roundRect">
-            <a:avLst/>
-          </a:prstGeom>
-          <a:solidFill>
-            <a:srgbClr val="B44A2D">
-              <a:alpha val="62000"/>
-            </a:srgbClr>
-          </a:solidFill>
-          <a:ln w="12700">
-            <a:solidFill>
-              <a:srgbClr val="FFFFFF">
-                <a:alpha val="0"/>
-              </a:srgbClr>
-            </a:solidFill>
-            <a:prstDash val="solid"/>
-          </a:ln>
-        </p:spPr>
-      </p:sp>
-      <p:sp>
-        <p:nvSpPr>
-          <p:cNvPr id="13" name="element_d35232b0ffd5e37581214e15fb92c5ac"/>
+              <a:t>Launch the smallest credible move</a:t>
+            </a:r>
+            <a:endParaRPr lang="en-US" sz="1400" dirty="0"/>
+          </a:p>
+        </p:txBody>
+      </p:sp>
+      <p:sp>
+        <p:nvSpPr>
+          <p:cNvPr id="12" name="element_d35232b0ffd5e37581214e15fb92c5ac"/>
           <p:cNvSpPr txBox="1"/>
           <p:nvPr/>
         </p:nvSpPr>
@@ -6784,7 +6586,7 @@
       </p:sp>
       <p:sp>
         <p:nvSpPr>
-          <p:cNvPr id="14" name="element_a67a90970183e6f2ab7a1b083f879bf6"/>
+          <p:cNvPr id="13" name="element_a67a90970183e6f2ab7a1b083f879bf6"/>
           <p:cNvSpPr txBox="1"/>
           <p:nvPr/>
         </p:nvSpPr>
@@ -7547,8 +7349,8 @@
         </p:nvSpPr>
         <p:spPr>
           <a:xfrm>
-            <a:off x="731502" y="1371600"/>
-            <a:ext cx="5852014" cy="3840480"/>
+            <a:off x="731502" y="1577340"/>
+            <a:ext cx="5608180" cy="3566160"/>
           </a:xfrm>
           <a:prstGeom prst="roundRect">
             <a:avLst/>
@@ -7576,8 +7378,8 @@
         </p:nvSpPr>
         <p:spPr>
           <a:xfrm>
-            <a:off x="2253025" y="1762506"/>
-            <a:ext cx="241396" cy="2400300"/>
+            <a:off x="2296915" y="1977847"/>
+            <a:ext cx="249930" cy="2880360"/>
           </a:xfrm>
           <a:prstGeom prst="roundRect">
             <a:avLst/>
@@ -7605,8 +7407,8 @@
         </p:nvSpPr>
         <p:spPr>
           <a:xfrm>
-            <a:off x="4607242" y="1762506"/>
-            <a:ext cx="241396" cy="2400300"/>
+            <a:off x="4732816" y="1977847"/>
+            <a:ext cx="249930" cy="2880360"/>
           </a:xfrm>
           <a:prstGeom prst="roundRect">
             <a:avLst/>
@@ -7634,8 +7436,8 @@
         </p:nvSpPr>
         <p:spPr>
           <a:xfrm>
-            <a:off x="2494421" y="3490722"/>
-            <a:ext cx="2111602" cy="216027"/>
+            <a:off x="2546845" y="4051706"/>
+            <a:ext cx="2187190" cy="259232"/>
           </a:xfrm>
           <a:prstGeom prst="roundRect">
             <a:avLst/>
@@ -7663,8 +7465,8 @@
         </p:nvSpPr>
         <p:spPr>
           <a:xfrm>
-            <a:off x="3666043" y="3202686"/>
-            <a:ext cx="442559" cy="528066"/>
+            <a:off x="3758700" y="3706063"/>
+            <a:ext cx="458408" cy="633679"/>
           </a:xfrm>
           <a:prstGeom prst="roundRect">
             <a:avLst/>
@@ -7824,8 +7626,8 @@
         </p:nvSpPr>
         <p:spPr>
           <a:xfrm>
-            <a:off x="7315017" y="5417820"/>
-            <a:ext cx="4145176" cy="548640"/>
+            <a:off x="7315017" y="5280660"/>
+            <a:ext cx="4145176" cy="754380"/>
           </a:xfrm>
           <a:prstGeom prst="rect">
             <a:avLst/>

</xml_diff>

<commit_message>
fix(nodeslide): close live geometry regressions (#164)
</commit_message>
<xml_diff>
--- a/evidence/scene-continuity-v2/generated/risk-committee-scene-continuity.pptx
+++ b/evidence/scene-continuity-v2/generated/risk-committee-scene-continuity.pptx
@@ -702,14 +702,11 @@
           <a:p>
             <a:r>
               <a:rPr lang="en-US" dirty="0"/>
-              <a:t>Narrative role: Proof. Composition grammar: scene-stage. Keep the spoken transition focused on "Agree how success will be judged before the next decision."
+              <a:t>Narrative role: Proof. Composition grammar: asymmetric-editorial. Keep the spoken transition focused on "Agree how success will be judged before the next decision."
 Evidence note: Content is based on the supplied creation brief. Illustrative examples are not independently verified; replace them with measured evidence before external publication.
 NodeSlide sources
 [source_26bf56ae628059912a6bb17d7978e1df] Build exactly 12 slides for a risk committee deciding whether an AI release may… — creation brief
 Citation: Build exactly 12 slides for a risk committee deciding whether an AI release may proceed. Use only supplied qualitative evidence. Move the guarded threshold from exposed uncertainty through inspection to an explicit release state. Do not invent figures, weights, thresholds, formulas, dates, or operating rules.
-Disclaimer: Internal working material
-[source_b8f449739f99d11a2b90824fc411ebb2] Brief success criteria
-Citation: Preserve all twelve narrative jobs; Separate supplied evidence from open assumptions; Name the decision owner and next checkpoint
 Disclaimer: Internal working material</a:t>
             </a:r>
             <a:endParaRPr lang="en-US" dirty="0"/>
@@ -1173,11 +1170,14 @@
           <a:p>
             <a:r>
               <a:rPr lang="en-US" dirty="0"/>
-              <a:t>Narrative role: Evidence / 05. Composition grammar: comparison-field. Keep the spoken transition focused on "Define proof before asking for commitment."
+              <a:t>Narrative role: Evidence / 05. Composition grammar: scene-stage. Keep the spoken transition focused on "Define proof before asking for commitment."
 Evidence note: Content is based on the supplied creation brief. Illustrative examples are not independently verified; replace them with measured evidence before external publication.
 NodeSlide sources
 [source_26bf56ae628059912a6bb17d7978e1df] Build exactly 12 slides for a risk committee deciding whether an AI release may… — creation brief
 Citation: Build exactly 12 slides for a risk committee deciding whether an AI release may proceed. Use only supplied qualitative evidence. Move the guarded threshold from exposed uncertainty through inspection to an explicit release state. Do not invent figures, weights, thresholds, formulas, dates, or operating rules.
+Disclaimer: Internal working material
+[source_b8f449739f99d11a2b90824fc411ebb2] Brief success criteria
+Citation: Preserve all twelve narrative jobs; Separate supplied evidence from open assumptions; Name the decision owner and next checkpoint
 Disclaimer: Internal working material</a:t>
             </a:r>
             <a:endParaRPr lang="en-US" dirty="0"/>
@@ -1266,11 +1266,14 @@
           <a:p>
             <a:r>
               <a:rPr lang="en-US" dirty="0"/>
-              <a:t>Narrative role: Delivery / 06. Composition grammar: asymmetric-editorial. Keep the spoken transition focused on "Start narrow, learn quickly, and preserve room to adapt."
+              <a:t>Narrative role: Delivery / 06. Composition grammar: scene-stage. Keep the spoken transition focused on "Start narrow, learn quickly, and preserve room to adapt."
 Evidence note: Content is based on the supplied creation brief. Illustrative examples are not independently verified; replace them with measured evidence before external publication.
 NodeSlide sources
 [source_26bf56ae628059912a6bb17d7978e1df] Build exactly 12 slides for a risk committee deciding whether an AI release may… — creation brief
 Citation: Build exactly 12 slides for a risk committee deciding whether an AI release may proceed. Use only supplied qualitative evidence. Move the guarded threshold from exposed uncertainty through inspection to an explicit release state. Do not invent figures, weights, thresholds, formulas, dates, or operating rules.
+Disclaimer: Internal working material
+[source_b8f449739f99d11a2b90824fc411ebb2] Brief success criteria
+Citation: Preserve all twelve narrative jobs; Separate supplied evidence from open assumptions; Name the decision owner and next checkpoint
 Disclaimer: Internal working material</a:t>
             </a:r>
             <a:endParaRPr lang="en-US" dirty="0"/>
@@ -2349,8 +2352,8 @@
         </p:nvSpPr>
         <p:spPr>
           <a:xfrm>
-            <a:off x="731502" y="1371600"/>
-            <a:ext cx="5852014" cy="3840480"/>
+            <a:off x="731502" y="1234440"/>
+            <a:ext cx="5852014" cy="4114800"/>
           </a:xfrm>
           <a:prstGeom prst="roundRect">
             <a:avLst/>
@@ -2378,8 +2381,8 @@
         </p:nvSpPr>
         <p:spPr>
           <a:xfrm>
-            <a:off x="2078684" y="1762506"/>
-            <a:ext cx="241396" cy="2400300"/>
+            <a:off x="2167683" y="1645920"/>
+            <a:ext cx="262121" cy="3429000"/>
           </a:xfrm>
           <a:prstGeom prst="roundRect">
             <a:avLst/>
@@ -2407,8 +2410,8 @@
         </p:nvSpPr>
         <p:spPr>
           <a:xfrm>
-            <a:off x="4781583" y="1762506"/>
-            <a:ext cx="241396" cy="2400300"/>
+            <a:off x="5103444" y="1645920"/>
+            <a:ext cx="262121" cy="3429000"/>
           </a:xfrm>
           <a:prstGeom prst="roundRect">
             <a:avLst/>
@@ -2436,8 +2439,8 @@
         </p:nvSpPr>
         <p:spPr>
           <a:xfrm>
-            <a:off x="2320080" y="3490722"/>
-            <a:ext cx="2463942" cy="216027"/>
+            <a:off x="2429805" y="4114800"/>
+            <a:ext cx="2676077" cy="308610"/>
           </a:xfrm>
           <a:prstGeom prst="roundRect">
             <a:avLst/>
@@ -2465,8 +2468,8 @@
         </p:nvSpPr>
         <p:spPr>
           <a:xfrm>
-            <a:off x="4301230" y="3202686"/>
-            <a:ext cx="442559" cy="528066"/>
+            <a:off x="4581639" y="3703320"/>
+            <a:ext cx="480353" cy="754380"/>
           </a:xfrm>
           <a:prstGeom prst="roundRect">
             <a:avLst/>
@@ -2626,8 +2629,8 @@
         </p:nvSpPr>
         <p:spPr>
           <a:xfrm>
-            <a:off x="7315017" y="5417820"/>
-            <a:ext cx="4145176" cy="548640"/>
+            <a:off x="7315017" y="5280660"/>
+            <a:ext cx="4145176" cy="754380"/>
           </a:xfrm>
           <a:prstGeom prst="rect">
             <a:avLst/>
@@ -2813,153 +2816,14 @@
       </p:sp>
       <p:sp>
         <p:nvSpPr>
-          <p:cNvPr id="3" name="element_cbf20ee37be6dd144c4a017ab3b8fd0c"/>
-          <p:cNvSpPr/>
-          <p:nvPr/>
-        </p:nvSpPr>
-        <p:spPr>
-          <a:xfrm>
-            <a:off x="5608180" y="1371600"/>
-            <a:ext cx="5852014" cy="3840480"/>
-          </a:xfrm>
-          <a:prstGeom prst="roundRect">
-            <a:avLst/>
-          </a:prstGeom>
-          <a:solidFill>
-            <a:srgbClr val="F2DED3">
-              <a:alpha val="22000"/>
-            </a:srgbClr>
-          </a:solidFill>
-          <a:ln w="12700">
-            <a:solidFill>
-              <a:srgbClr val="FFFFFF">
-                <a:alpha val="0"/>
-              </a:srgbClr>
-            </a:solidFill>
-            <a:prstDash val="solid"/>
-          </a:ln>
-        </p:spPr>
-      </p:sp>
-      <p:sp>
-        <p:nvSpPr>
-          <p:cNvPr id="4" name="element_b2854094ce033f66e0f2567d3da73b0e"/>
-          <p:cNvSpPr/>
-          <p:nvPr/>
-        </p:nvSpPr>
-        <p:spPr>
-          <a:xfrm>
-            <a:off x="6866363" y="1762506"/>
-            <a:ext cx="241396" cy="2400300"/>
-          </a:xfrm>
-          <a:prstGeom prst="roundRect">
-            <a:avLst/>
-          </a:prstGeom>
-          <a:solidFill>
-            <a:srgbClr val="34452C"/>
-          </a:solidFill>
-          <a:ln w="12700">
-            <a:solidFill>
-              <a:srgbClr val="FFFFFF">
-                <a:alpha val="0"/>
-              </a:srgbClr>
-            </a:solidFill>
-            <a:prstDash val="solid"/>
-          </a:ln>
-        </p:spPr>
-      </p:sp>
-      <p:sp>
-        <p:nvSpPr>
-          <p:cNvPr id="5" name="element_48402ebbe3a8ec3b2a5f26360b92c1dc"/>
-          <p:cNvSpPr/>
-          <p:nvPr/>
-        </p:nvSpPr>
-        <p:spPr>
-          <a:xfrm>
-            <a:off x="9747260" y="1762506"/>
-            <a:ext cx="241396" cy="2400300"/>
-          </a:xfrm>
-          <a:prstGeom prst="roundRect">
-            <a:avLst/>
-          </a:prstGeom>
-          <a:solidFill>
-            <a:srgbClr val="34452C"/>
-          </a:solidFill>
-          <a:ln w="12700">
-            <a:solidFill>
-              <a:srgbClr val="FFFFFF">
-                <a:alpha val="0"/>
-              </a:srgbClr>
-            </a:solidFill>
-            <a:prstDash val="solid"/>
-          </a:ln>
-        </p:spPr>
-      </p:sp>
-      <p:sp>
-        <p:nvSpPr>
-          <p:cNvPr id="6" name="element_25e116853f5c838cfc7009e9ec971251"/>
-          <p:cNvSpPr/>
-          <p:nvPr/>
-        </p:nvSpPr>
-        <p:spPr>
-          <a:xfrm>
-            <a:off x="7107758" y="3490722"/>
-            <a:ext cx="2640721" cy="216027"/>
-          </a:xfrm>
-          <a:prstGeom prst="roundRect">
-            <a:avLst/>
-          </a:prstGeom>
-          <a:solidFill>
-            <a:srgbClr val="F2DED3">
-              <a:alpha val="74000"/>
-            </a:srgbClr>
-          </a:solidFill>
-          <a:ln w="12700">
-            <a:solidFill>
-              <a:srgbClr val="FFFFFF">
-                <a:alpha val="0"/>
-              </a:srgbClr>
-            </a:solidFill>
-            <a:prstDash val="solid"/>
-          </a:ln>
-        </p:spPr>
-      </p:sp>
-      <p:sp>
-        <p:nvSpPr>
-          <p:cNvPr id="7" name="element_211bb930c058f5f9c6b025ea955129de"/>
-          <p:cNvSpPr/>
-          <p:nvPr/>
-        </p:nvSpPr>
-        <p:spPr>
-          <a:xfrm>
-            <a:off x="9497331" y="3202686"/>
-            <a:ext cx="442559" cy="528066"/>
-          </a:xfrm>
-          <a:prstGeom prst="roundRect">
-            <a:avLst/>
-          </a:prstGeom>
-          <a:solidFill>
-            <a:srgbClr val="B44A2D"/>
-          </a:solidFill>
-          <a:ln w="12700">
-            <a:solidFill>
-              <a:srgbClr val="FFFFFF">
-                <a:alpha val="0"/>
-              </a:srgbClr>
-            </a:solidFill>
-            <a:prstDash val="solid"/>
-          </a:ln>
-        </p:spPr>
-      </p:sp>
-      <p:sp>
-        <p:nvSpPr>
-          <p:cNvPr id="8" name="element_7992db25ff6c1ed0fdaffccc48b775c3"/>
+          <p:cNvPr id="3" name="element_7992db25ff6c1ed0fdaffccc48b775c3"/>
           <p:cNvSpPr txBox="1"/>
           <p:nvPr/>
         </p:nvSpPr>
         <p:spPr>
           <a:xfrm>
-            <a:off x="731502" y="445770"/>
-            <a:ext cx="3657509" cy="342900"/>
+            <a:off x="6461598" y="445770"/>
+            <a:ext cx="4876678" cy="342900"/>
           </a:xfrm>
           <a:prstGeom prst="rect">
             <a:avLst/>
@@ -2996,14 +2860,14 @@
       </p:sp>
       <p:sp>
         <p:nvSpPr>
-          <p:cNvPr id="9" name="element_47b50223155bcfc9b1a97c2b9c8f2e28"/>
+          <p:cNvPr id="4" name="element_47b50223155bcfc9b1a97c2b9c8f2e28"/>
           <p:cNvSpPr txBox="1"/>
           <p:nvPr/>
         </p:nvSpPr>
         <p:spPr>
           <a:xfrm>
-            <a:off x="731502" y="1234440"/>
-            <a:ext cx="4145176" cy="2311146"/>
+            <a:off x="853419" y="1097280"/>
+            <a:ext cx="10484858" cy="1234440"/>
           </a:xfrm>
           <a:prstGeom prst="rect">
             <a:avLst/>
@@ -3019,12 +2883,12 @@
           <a:p>
             <a:pPr algn="l" indent="0" marL="0">
               <a:lnSpc>
-                <a:spcPct val="104000"/>
+                <a:spcPct val="105000"/>
               </a:lnSpc>
               <a:buNone/>
             </a:pPr>
             <a:r>
-              <a:rPr lang="en-US" sz="3500" b="1" spc="-50" kern="0" dirty="0">
+              <a:rPr lang="en-US" sz="4200" b="1" spc="-60" kern="0" dirty="0">
                 <a:solidFill>
                   <a:srgbClr val="26221D"/>
                 </a:solidFill>
@@ -3034,20 +2898,20 @@
               </a:rPr>
               <a:t>Agree how success will be judged before the next decision.</a:t>
             </a:r>
-            <a:endParaRPr lang="en-US" sz="3500" dirty="0"/>
-          </a:p>
-        </p:txBody>
-      </p:sp>
-      <p:sp>
-        <p:nvSpPr>
-          <p:cNvPr id="10" name="element_18d6c8ab2ea21a54310780349c453eb5"/>
+            <a:endParaRPr lang="en-US" sz="4200" dirty="0"/>
+          </a:p>
+        </p:txBody>
+      </p:sp>
+      <p:sp>
+        <p:nvSpPr>
+          <p:cNvPr id="5" name="element_18d6c8ab2ea21a54310780349c453eb5"/>
           <p:cNvSpPr txBox="1"/>
           <p:nvPr/>
         </p:nvSpPr>
         <p:spPr>
           <a:xfrm>
-            <a:off x="731502" y="3785616"/>
-            <a:ext cx="4145176" cy="1357884"/>
+            <a:off x="1706837" y="2743200"/>
+            <a:ext cx="9631439" cy="1028700"/>
           </a:xfrm>
           <a:prstGeom prst="rect">
             <a:avLst/>
@@ -3063,12 +2927,12 @@
           <a:p>
             <a:pPr algn="l" indent="0" marL="0">
               <a:lnSpc>
-                <a:spcPct val="138000"/>
+                <a:spcPct val="135000"/>
               </a:lnSpc>
               <a:buNone/>
             </a:pPr>
             <a:r>
-              <a:rPr lang="en-US" sz="1600" dirty="0">
+              <a:rPr lang="en-US" sz="1800" dirty="0">
                 <a:solidFill>
                   <a:srgbClr val="756B61"/>
                 </a:solidFill>
@@ -3078,20 +2942,20 @@
               </a:rPr>
               <a:t>Use the supplied success criteria as review questions; do not turn them into invented scores or weights.</a:t>
             </a:r>
-            <a:endParaRPr lang="en-US" sz="1600" dirty="0"/>
-          </a:p>
-        </p:txBody>
-      </p:sp>
-      <p:sp>
-        <p:nvSpPr>
-          <p:cNvPr id="11" name="element_bda5bc580a5647bac7ed278aa99ba3fb"/>
+            <a:endParaRPr lang="en-US" sz="1800" dirty="0"/>
+          </a:p>
+        </p:txBody>
+      </p:sp>
+      <p:sp>
+        <p:nvSpPr>
+          <p:cNvPr id="6" name="element_41a16164cc258ac30956cbd4640306f6"/>
           <p:cNvSpPr txBox="1"/>
           <p:nvPr/>
         </p:nvSpPr>
         <p:spPr>
           <a:xfrm>
-            <a:off x="731502" y="5417820"/>
-            <a:ext cx="4145176" cy="548640"/>
+            <a:off x="975336" y="3909060"/>
+            <a:ext cx="4023259" cy="518465"/>
           </a:xfrm>
           <a:prstGeom prst="rect">
             <a:avLst/>
@@ -3100,41 +2964,239 @@
           <a:ln/>
         </p:spPr>
         <p:txBody>
-          <a:bodyPr wrap="square" lIns="152400" tIns="152400" rIns="152400" bIns="152400" rtlCol="0" anchor="t">
+          <a:bodyPr wrap="square" lIns="0" tIns="0" rIns="0" bIns="0" rtlCol="0" anchor="t">
             <a:normAutofit/>
           </a:bodyPr>
           <a:lstStyle/>
           <a:p>
             <a:pPr algn="l" indent="0" marL="0">
               <a:lnSpc>
-                <a:spcPct val="125000"/>
+                <a:spcPct val="120000"/>
               </a:lnSpc>
               <a:buNone/>
             </a:pPr>
             <a:r>
-              <a:rPr lang="en-US" sz="1600" b="1" dirty="0">
+              <a:rPr lang="en-US" sz="1700" dirty="0">
                 <a:solidFill>
-                  <a:srgbClr val="34452C"/>
+                  <a:srgbClr val="26221D"/>
                 </a:solidFill>
                 <a:latin typeface="Geist Variable" pitchFamily="34" charset="0"/>
                 <a:ea typeface="Geist Variable" pitchFamily="34" charset="-122"/>
                 <a:cs typeface="Geist Variable" pitchFamily="34" charset="-120"/>
               </a:rPr>
-              <a:t>Preserve all twelve narrative jobs</a:t>
-            </a:r>
-            <a:endParaRPr lang="en-US" sz="1600" dirty="0"/>
-          </a:p>
-        </p:txBody>
-      </p:sp>
-      <p:sp>
-        <p:nvSpPr>
-          <p:cNvPr id="12" name="element_d7b507fb8a349bc29e7f736b6a316300"/>
+              <a:t>01  Preserve all twelve narrative jobs</a:t>
+            </a:r>
+            <a:endParaRPr lang="en-US" sz="1700" dirty="0"/>
+          </a:p>
+        </p:txBody>
+      </p:sp>
+      <p:sp>
+        <p:nvSpPr>
+          <p:cNvPr id="7" name="element_af08544760b746ffbd9c026b0123c4ba"/>
           <p:cNvSpPr txBox="1"/>
           <p:nvPr/>
         </p:nvSpPr>
         <p:spPr>
           <a:xfrm>
-            <a:off x="853419" y="6377940"/>
+            <a:off x="975336" y="4633265"/>
+            <a:ext cx="4023259" cy="518465"/>
+          </a:xfrm>
+          <a:prstGeom prst="rect">
+            <a:avLst/>
+          </a:prstGeom>
+          <a:noFill/>
+          <a:ln/>
+        </p:spPr>
+        <p:txBody>
+          <a:bodyPr wrap="square" lIns="0" tIns="0" rIns="0" bIns="0" rtlCol="0" anchor="t">
+            <a:normAutofit/>
+          </a:bodyPr>
+          <a:lstStyle/>
+          <a:p>
+            <a:pPr algn="l" indent="0" marL="0">
+              <a:lnSpc>
+                <a:spcPct val="120000"/>
+              </a:lnSpc>
+              <a:buNone/>
+            </a:pPr>
+            <a:r>
+              <a:rPr lang="en-US" sz="1700" dirty="0">
+                <a:solidFill>
+                  <a:srgbClr val="26221D"/>
+                </a:solidFill>
+                <a:latin typeface="Geist Variable" pitchFamily="34" charset="0"/>
+                <a:ea typeface="Geist Variable" pitchFamily="34" charset="-122"/>
+                <a:cs typeface="Geist Variable" pitchFamily="34" charset="-120"/>
+              </a:rPr>
+              <a:t>02  Separate supplied evidence from open assumptions</a:t>
+            </a:r>
+            <a:endParaRPr lang="en-US" sz="1700" dirty="0"/>
+          </a:p>
+        </p:txBody>
+      </p:sp>
+      <p:sp>
+        <p:nvSpPr>
+          <p:cNvPr id="8" name="element_24d4817d32ebadb03e5b2868e34409d4"/>
+          <p:cNvSpPr txBox="1"/>
+          <p:nvPr/>
+        </p:nvSpPr>
+        <p:spPr>
+          <a:xfrm>
+            <a:off x="975336" y="5356784"/>
+            <a:ext cx="4023259" cy="518465"/>
+          </a:xfrm>
+          <a:prstGeom prst="rect">
+            <a:avLst/>
+          </a:prstGeom>
+          <a:noFill/>
+          <a:ln/>
+        </p:spPr>
+        <p:txBody>
+          <a:bodyPr wrap="square" lIns="0" tIns="0" rIns="0" bIns="0" rtlCol="0" anchor="t">
+            <a:normAutofit/>
+          </a:bodyPr>
+          <a:lstStyle/>
+          <a:p>
+            <a:pPr algn="l" indent="0" marL="0">
+              <a:lnSpc>
+                <a:spcPct val="120000"/>
+              </a:lnSpc>
+              <a:buNone/>
+            </a:pPr>
+            <a:r>
+              <a:rPr lang="en-US" sz="1700" dirty="0">
+                <a:solidFill>
+                  <a:srgbClr val="26221D"/>
+                </a:solidFill>
+                <a:latin typeface="Geist Variable" pitchFamily="34" charset="0"/>
+                <a:ea typeface="Geist Variable" pitchFamily="34" charset="-122"/>
+                <a:cs typeface="Geist Variable" pitchFamily="34" charset="-120"/>
+              </a:rPr>
+              <a:t>03  Name the decision owner and next checkpoint</a:t>
+            </a:r>
+            <a:endParaRPr lang="en-US" sz="1700" dirty="0"/>
+          </a:p>
+        </p:txBody>
+      </p:sp>
+      <p:sp>
+        <p:nvSpPr>
+          <p:cNvPr id="9" name="element_b2854094ce033f66e0f2567d3da73b0e"/>
+          <p:cNvSpPr/>
+          <p:nvPr/>
+        </p:nvSpPr>
+        <p:spPr>
+          <a:xfrm>
+            <a:off x="3177156" y="356616"/>
+            <a:ext cx="146300" cy="685800"/>
+          </a:xfrm>
+          <a:prstGeom prst="roundRect">
+            <a:avLst/>
+          </a:prstGeom>
+          <a:solidFill>
+            <a:srgbClr val="34452C"/>
+          </a:solidFill>
+          <a:ln w="12700">
+            <a:solidFill>
+              <a:srgbClr val="FFFFFF">
+                <a:alpha val="0"/>
+              </a:srgbClr>
+            </a:solidFill>
+            <a:prstDash val="solid"/>
+          </a:ln>
+        </p:spPr>
+      </p:sp>
+      <p:sp>
+        <p:nvSpPr>
+          <p:cNvPr id="10" name="element_48402ebbe3a8ec3b2a5f26360b92c1dc"/>
+          <p:cNvSpPr/>
+          <p:nvPr/>
+        </p:nvSpPr>
+        <p:spPr>
+          <a:xfrm>
+            <a:off x="1431305" y="356616"/>
+            <a:ext cx="146300" cy="685800"/>
+          </a:xfrm>
+          <a:prstGeom prst="roundRect">
+            <a:avLst/>
+          </a:prstGeom>
+          <a:solidFill>
+            <a:srgbClr val="34452C"/>
+          </a:solidFill>
+          <a:ln w="12700">
+            <a:solidFill>
+              <a:srgbClr val="FFFFFF">
+                <a:alpha val="0"/>
+              </a:srgbClr>
+            </a:solidFill>
+            <a:prstDash val="solid"/>
+          </a:ln>
+        </p:spPr>
+      </p:sp>
+      <p:sp>
+        <p:nvSpPr>
+          <p:cNvPr id="11" name="element_25e116853f5c838cfc7009e9ec971251"/>
+          <p:cNvSpPr/>
+          <p:nvPr/>
+        </p:nvSpPr>
+        <p:spPr>
+          <a:xfrm>
+            <a:off x="1576386" y="850392"/>
+            <a:ext cx="1600770" cy="68580"/>
+          </a:xfrm>
+          <a:prstGeom prst="roundRect">
+            <a:avLst/>
+          </a:prstGeom>
+          <a:solidFill>
+            <a:srgbClr val="F2DED3">
+              <a:alpha val="74000"/>
+            </a:srgbClr>
+          </a:solidFill>
+          <a:ln w="12700">
+            <a:solidFill>
+              <a:srgbClr val="FFFFFF">
+                <a:alpha val="0"/>
+              </a:srgbClr>
+            </a:solidFill>
+            <a:prstDash val="solid"/>
+          </a:ln>
+        </p:spPr>
+      </p:sp>
+      <p:sp>
+        <p:nvSpPr>
+          <p:cNvPr id="12" name="element_211bb930c058f5f9c6b025ea955129de"/>
+          <p:cNvSpPr/>
+          <p:nvPr/>
+        </p:nvSpPr>
+        <p:spPr>
+          <a:xfrm>
+            <a:off x="1460565" y="768096"/>
+            <a:ext cx="268217" cy="150876"/>
+          </a:xfrm>
+          <a:prstGeom prst="roundRect">
+            <a:avLst/>
+          </a:prstGeom>
+          <a:solidFill>
+            <a:srgbClr val="B44A2D"/>
+          </a:solidFill>
+          <a:ln w="12700">
+            <a:solidFill>
+              <a:srgbClr val="FFFFFF">
+                <a:alpha val="0"/>
+              </a:srgbClr>
+            </a:solidFill>
+            <a:prstDash val="solid"/>
+          </a:ln>
+        </p:spPr>
+      </p:sp>
+      <p:sp>
+        <p:nvSpPr>
+          <p:cNvPr id="13" name="element_d7b507fb8a349bc29e7f736b6a316300"/>
+          <p:cNvSpPr txBox="1"/>
+          <p:nvPr/>
+        </p:nvSpPr>
+        <p:spPr>
+          <a:xfrm>
+            <a:off x="2560256" y="6377940"/>
             <a:ext cx="8778021" cy="240030"/>
           </a:xfrm>
           <a:prstGeom prst="rect">
@@ -3172,13 +3234,13 @@
       </p:sp>
       <p:sp>
         <p:nvSpPr>
-          <p:cNvPr id="13" name="element_93c05a6fef75185268d70ddaaf947c84"/>
+          <p:cNvPr id="14" name="element_93c05a6fef75185268d70ddaaf947c84"/>
           <p:cNvSpPr txBox="1"/>
           <p:nvPr/>
         </p:nvSpPr>
         <p:spPr>
           <a:xfrm>
-            <a:off x="10728692" y="6309360"/>
+            <a:off x="731502" y="6309360"/>
             <a:ext cx="731502" cy="342900"/>
           </a:xfrm>
           <a:prstGeom prst="rect">
@@ -5689,14 +5751,159 @@
       </p:sp>
       <p:sp>
         <p:nvSpPr>
-          <p:cNvPr id="3" name="element_53b2a433e8ef3a6bd8d138ad80445754"/>
+          <p:cNvPr id="3" name="element_f3f59aab8c5e2645319ab05b4fa0af13"/>
+          <p:cNvSpPr/>
+          <p:nvPr/>
+        </p:nvSpPr>
+        <p:spPr>
+          <a:xfrm>
+            <a:off x="6339682" y="1920240"/>
+            <a:ext cx="5120512" cy="3017520"/>
+          </a:xfrm>
+          <a:prstGeom prst="roundRect">
+            <a:avLst/>
+          </a:prstGeom>
+          <a:solidFill>
+            <a:srgbClr val="F2DED3">
+              <a:alpha val="22000"/>
+            </a:srgbClr>
+          </a:solidFill>
+          <a:ln w="12700">
+            <a:solidFill>
+              <a:srgbClr val="FFFFFF">
+                <a:alpha val="0"/>
+              </a:srgbClr>
+            </a:solidFill>
+            <a:prstDash val="solid"/>
+          </a:ln>
+        </p:spPr>
+      </p:sp>
+      <p:sp>
+        <p:nvSpPr>
+          <p:cNvPr id="4" name="element_80139f17b05b16ea962bd6c5827bc565"/>
+          <p:cNvSpPr/>
+          <p:nvPr/>
+        </p:nvSpPr>
+        <p:spPr>
+          <a:xfrm>
+            <a:off x="8028231" y="2309774"/>
+            <a:ext cx="225546" cy="2331720"/>
+          </a:xfrm>
+          <a:prstGeom prst="roundRect">
+            <a:avLst/>
+          </a:prstGeom>
+          <a:solidFill>
+            <a:srgbClr val="34452C">
+              <a:alpha val="54000"/>
+            </a:srgbClr>
+          </a:solidFill>
+          <a:ln w="12700">
+            <a:solidFill>
+              <a:srgbClr val="FFFFFF">
+                <a:alpha val="0"/>
+              </a:srgbClr>
+            </a:solidFill>
+            <a:prstDash val="solid"/>
+          </a:ln>
+        </p:spPr>
+      </p:sp>
+      <p:sp>
+        <p:nvSpPr>
+          <p:cNvPr id="5" name="element_09429fc6a045697dc92d8b9c551a829f"/>
+          <p:cNvSpPr/>
+          <p:nvPr/>
+        </p:nvSpPr>
+        <p:spPr>
+          <a:xfrm>
+            <a:off x="9735069" y="2309774"/>
+            <a:ext cx="225546" cy="2331720"/>
+          </a:xfrm>
+          <a:prstGeom prst="roundRect">
+            <a:avLst/>
+          </a:prstGeom>
+          <a:solidFill>
+            <a:srgbClr val="34452C">
+              <a:alpha val="54000"/>
+            </a:srgbClr>
+          </a:solidFill>
+          <a:ln w="12700">
+            <a:solidFill>
+              <a:srgbClr val="FFFFFF">
+                <a:alpha val="0"/>
+              </a:srgbClr>
+            </a:solidFill>
+            <a:prstDash val="solid"/>
+          </a:ln>
+        </p:spPr>
+      </p:sp>
+      <p:sp>
+        <p:nvSpPr>
+          <p:cNvPr id="6" name="element_7cafa24ba8e6bd67c7d9638ffc439efa"/>
+          <p:cNvSpPr/>
+          <p:nvPr/>
+        </p:nvSpPr>
+        <p:spPr>
+          <a:xfrm>
+            <a:off x="8253778" y="3988613"/>
+            <a:ext cx="1481291" cy="209855"/>
+          </a:xfrm>
+          <a:prstGeom prst="roundRect">
+            <a:avLst/>
+          </a:prstGeom>
+          <a:solidFill>
+            <a:srgbClr val="F2DED3">
+              <a:alpha val="57000"/>
+            </a:srgbClr>
+          </a:solidFill>
+          <a:ln w="12700">
+            <a:solidFill>
+              <a:srgbClr val="FFFFFF">
+                <a:alpha val="0"/>
+              </a:srgbClr>
+            </a:solidFill>
+            <a:prstDash val="solid"/>
+          </a:ln>
+        </p:spPr>
+      </p:sp>
+      <p:sp>
+        <p:nvSpPr>
+          <p:cNvPr id="7" name="element_12fee635c3eb15f87ee7f7b760203956"/>
+          <p:cNvSpPr/>
+          <p:nvPr/>
+        </p:nvSpPr>
+        <p:spPr>
+          <a:xfrm>
+            <a:off x="8208668" y="3708806"/>
+            <a:ext cx="413298" cy="512978"/>
+          </a:xfrm>
+          <a:prstGeom prst="roundRect">
+            <a:avLst/>
+          </a:prstGeom>
+          <a:solidFill>
+            <a:srgbClr val="B44A2D">
+              <a:alpha val="54000"/>
+            </a:srgbClr>
+          </a:solidFill>
+          <a:ln w="12700">
+            <a:solidFill>
+              <a:srgbClr val="FFFFFF">
+                <a:alpha val="0"/>
+              </a:srgbClr>
+            </a:solidFill>
+            <a:prstDash val="solid"/>
+          </a:ln>
+        </p:spPr>
+      </p:sp>
+      <p:sp>
+        <p:nvSpPr>
+          <p:cNvPr id="8" name="element_53b2a433e8ef3a6bd8d138ad80445754"/>
           <p:cNvSpPr txBox="1"/>
           <p:nvPr/>
         </p:nvSpPr>
         <p:spPr>
           <a:xfrm>
-            <a:off x="853419" y="445770"/>
-            <a:ext cx="4876678" cy="342900"/>
+            <a:off x="731502" y="445770"/>
+            <a:ext cx="3657509" cy="342900"/>
           </a:xfrm>
           <a:prstGeom prst="rect">
             <a:avLst/>
@@ -5733,14 +5940,14 @@
       </p:sp>
       <p:sp>
         <p:nvSpPr>
-          <p:cNvPr id="4" name="element_01792f9e8d1815f7b370f8a6f9d84ffc"/>
+          <p:cNvPr id="9" name="element_01792f9e8d1815f7b370f8a6f9d84ffc"/>
           <p:cNvSpPr txBox="1"/>
           <p:nvPr/>
         </p:nvSpPr>
         <p:spPr>
           <a:xfrm>
-            <a:off x="853419" y="1028700"/>
-            <a:ext cx="9631439" cy="960120"/>
+            <a:off x="731502" y="1234440"/>
+            <a:ext cx="4876678" cy="2258339"/>
           </a:xfrm>
           <a:prstGeom prst="rect">
             <a:avLst/>
@@ -5756,12 +5963,12 @@
           <a:p>
             <a:pPr algn="l" indent="0" marL="0">
               <a:lnSpc>
-                <a:spcPct val="105000"/>
+                <a:spcPct val="104000"/>
               </a:lnSpc>
               <a:buNone/>
             </a:pPr>
             <a:r>
-              <a:rPr lang="en-US" sz="3600" b="1" spc="-40" kern="0" dirty="0">
+              <a:rPr lang="en-US" sz="3800" b="1" spc="-50" kern="0" dirty="0">
                 <a:solidFill>
                   <a:srgbClr val="26221D"/>
                 </a:solidFill>
@@ -5771,20 +5978,20 @@
               </a:rPr>
               <a:t>Define proof before asking for commitment.</a:t>
             </a:r>
-            <a:endParaRPr lang="en-US" sz="3600" dirty="0"/>
-          </a:p>
-        </p:txBody>
-      </p:sp>
-      <p:sp>
-        <p:nvSpPr>
-          <p:cNvPr id="5" name="element_44704871b8544e94d876edeb52c0099e"/>
+            <a:endParaRPr lang="en-US" sz="3800" dirty="0"/>
+          </a:p>
+        </p:txBody>
+      </p:sp>
+      <p:sp>
+        <p:nvSpPr>
+          <p:cNvPr id="10" name="element_aa94a395efe36a9ee0b532c5acb6bfae"/>
           <p:cNvSpPr txBox="1"/>
           <p:nvPr/>
         </p:nvSpPr>
         <p:spPr>
           <a:xfrm>
-            <a:off x="853419" y="2400300"/>
-            <a:ext cx="3251525" cy="548640"/>
+            <a:off x="731502" y="3732809"/>
+            <a:ext cx="4876678" cy="1410691"/>
           </a:xfrm>
           <a:prstGeom prst="rect">
             <a:avLst/>
@@ -5800,35 +6007,35 @@
           <a:p>
             <a:pPr algn="l" indent="0" marL="0">
               <a:lnSpc>
-                <a:spcPct val="120000"/>
+                <a:spcPct val="138000"/>
               </a:lnSpc>
               <a:buNone/>
             </a:pPr>
             <a:r>
-              <a:rPr lang="en-US" sz="2200" b="1" dirty="0">
+              <a:rPr lang="en-US" sz="1600" dirty="0">
                 <a:solidFill>
-                  <a:srgbClr val="B44A2D"/>
+                  <a:srgbClr val="756B61"/>
                 </a:solidFill>
-                <a:latin typeface="JetBrains Mono Variable" pitchFamily="34" charset="0"/>
-                <a:ea typeface="JetBrains Mono Variable" pitchFamily="34" charset="-122"/>
-                <a:cs typeface="JetBrains Mono Variable" pitchFamily="34" charset="-120"/>
+                <a:latin typeface="Geist Variable" pitchFamily="34" charset="0"/>
+                <a:ea typeface="Geist Variable" pitchFamily="34" charset="-122"/>
+                <a:cs typeface="Geist Variable" pitchFamily="34" charset="-120"/>
               </a:rPr>
-              <a:t>01</a:t>
-            </a:r>
-            <a:endParaRPr lang="en-US" sz="2200" dirty="0"/>
-          </a:p>
-        </p:txBody>
-      </p:sp>
-      <p:sp>
-        <p:nvSpPr>
-          <p:cNvPr id="6" name="element_2157ef83b010916f9b5dbcef830294ea"/>
+              <a:t>Use the brief’s success criteria as qualitative review questions until measured evidence is supplied.</a:t>
+            </a:r>
+            <a:endParaRPr lang="en-US" sz="1600" dirty="0"/>
+          </a:p>
+        </p:txBody>
+      </p:sp>
+      <p:sp>
+        <p:nvSpPr>
+          <p:cNvPr id="11" name="element_a78d40d8d28a9e2aaad0662cd5c02e6e"/>
           <p:cNvSpPr txBox="1"/>
           <p:nvPr/>
         </p:nvSpPr>
         <p:spPr>
           <a:xfrm>
-            <a:off x="853419" y="2948940"/>
-            <a:ext cx="3251525" cy="2331720"/>
+            <a:off x="731502" y="5280660"/>
+            <a:ext cx="4876678" cy="754380"/>
           </a:xfrm>
           <a:prstGeom prst="rect">
             <a:avLst/>
@@ -5837,21 +6044,21 @@
           <a:ln/>
         </p:spPr>
         <p:txBody>
-          <a:bodyPr wrap="square" lIns="0" tIns="0" rIns="0" bIns="0" rtlCol="0" anchor="t">
+          <a:bodyPr wrap="square" lIns="152400" tIns="152400" rIns="152400" bIns="152400" rtlCol="0" anchor="t">
             <a:normAutofit/>
           </a:bodyPr>
           <a:lstStyle/>
           <a:p>
             <a:pPr algn="l" indent="0" marL="0">
               <a:lnSpc>
-                <a:spcPct val="130000"/>
+                <a:spcPct val="125000"/>
               </a:lnSpc>
               <a:buNone/>
             </a:pPr>
             <a:r>
-              <a:rPr lang="en-US" sz="1700" dirty="0">
+              <a:rPr lang="en-US" sz="1600" b="1" dirty="0">
                 <a:solidFill>
-                  <a:srgbClr val="26221D"/>
+                  <a:srgbClr val="34452C"/>
                 </a:solidFill>
                 <a:latin typeface="Geist Variable" pitchFamily="34" charset="0"/>
                 <a:ea typeface="Geist Variable" pitchFamily="34" charset="-122"/>
@@ -5859,359 +6066,13 @@
               </a:rPr>
               <a:t>Preserve all twelve narrative jobs</a:t>
             </a:r>
-            <a:endParaRPr lang="en-US" sz="1700" dirty="0"/>
-          </a:p>
-        </p:txBody>
-      </p:sp>
-      <p:sp>
-        <p:nvSpPr>
-          <p:cNvPr id="7" name="element_8d5ff8f0f31852747fc6800e4b15997e"/>
-          <p:cNvSpPr/>
-          <p:nvPr/>
-        </p:nvSpPr>
-        <p:spPr>
-          <a:xfrm>
-            <a:off x="4287819" y="2400300"/>
-            <a:ext cx="121917" cy="2880360"/>
-          </a:xfrm>
-          <a:prstGeom prst="rect">
-            <a:avLst/>
-          </a:prstGeom>
-          <a:solidFill>
-            <a:srgbClr val="DED7CC"/>
-          </a:solidFill>
-          <a:ln w="12700">
-            <a:solidFill>
-              <a:srgbClr val="FFFFFF">
-                <a:alpha val="0"/>
-              </a:srgbClr>
-            </a:solidFill>
-            <a:prstDash val="solid"/>
-          </a:ln>
-        </p:spPr>
-      </p:sp>
-      <p:sp>
-        <p:nvSpPr>
-          <p:cNvPr id="8" name="element_9928458764e9ba4338e7aedbaa47f52b"/>
-          <p:cNvSpPr txBox="1"/>
-          <p:nvPr/>
-        </p:nvSpPr>
-        <p:spPr>
-          <a:xfrm>
-            <a:off x="4470695" y="2400300"/>
-            <a:ext cx="3251525" cy="548640"/>
-          </a:xfrm>
-          <a:prstGeom prst="rect">
-            <a:avLst/>
-          </a:prstGeom>
-          <a:noFill/>
-          <a:ln/>
-        </p:spPr>
-        <p:txBody>
-          <a:bodyPr wrap="square" lIns="0" tIns="0" rIns="0" bIns="0" rtlCol="0" anchor="t">
-            <a:normAutofit/>
-          </a:bodyPr>
-          <a:lstStyle/>
-          <a:p>
-            <a:pPr algn="l" indent="0" marL="0">
-              <a:lnSpc>
-                <a:spcPct val="120000"/>
-              </a:lnSpc>
-              <a:buNone/>
-            </a:pPr>
-            <a:r>
-              <a:rPr lang="en-US" sz="2200" b="1" dirty="0">
-                <a:solidFill>
-                  <a:srgbClr val="B44A2D"/>
-                </a:solidFill>
-                <a:latin typeface="JetBrains Mono Variable" pitchFamily="34" charset="0"/>
-                <a:ea typeface="JetBrains Mono Variable" pitchFamily="34" charset="-122"/>
-                <a:cs typeface="JetBrains Mono Variable" pitchFamily="34" charset="-120"/>
-              </a:rPr>
-              <a:t>02</a:t>
-            </a:r>
-            <a:endParaRPr lang="en-US" sz="2200" dirty="0"/>
-          </a:p>
-        </p:txBody>
-      </p:sp>
-      <p:sp>
-        <p:nvSpPr>
-          <p:cNvPr id="9" name="element_25ab8a0b9a34b1d2eda8d1deb1cb4ff5"/>
-          <p:cNvSpPr txBox="1"/>
-          <p:nvPr/>
-        </p:nvSpPr>
-        <p:spPr>
-          <a:xfrm>
-            <a:off x="4470695" y="2948940"/>
-            <a:ext cx="3251525" cy="2331720"/>
-          </a:xfrm>
-          <a:prstGeom prst="rect">
-            <a:avLst/>
-          </a:prstGeom>
-          <a:noFill/>
-          <a:ln/>
-        </p:spPr>
-        <p:txBody>
-          <a:bodyPr wrap="square" lIns="0" tIns="0" rIns="0" bIns="0" rtlCol="0" anchor="t">
-            <a:normAutofit/>
-          </a:bodyPr>
-          <a:lstStyle/>
-          <a:p>
-            <a:pPr algn="l" indent="0" marL="0">
-              <a:lnSpc>
-                <a:spcPct val="130000"/>
-              </a:lnSpc>
-              <a:buNone/>
-            </a:pPr>
-            <a:r>
-              <a:rPr lang="en-US" sz="1700" dirty="0">
-                <a:solidFill>
-                  <a:srgbClr val="26221D"/>
-                </a:solidFill>
-                <a:latin typeface="Geist Variable" pitchFamily="34" charset="0"/>
-                <a:ea typeface="Geist Variable" pitchFamily="34" charset="-122"/>
-                <a:cs typeface="Geist Variable" pitchFamily="34" charset="-120"/>
-              </a:rPr>
-              <a:t>Separate supplied evidence from open assumptions</a:t>
-            </a:r>
-            <a:endParaRPr lang="en-US" sz="1700" dirty="0"/>
-          </a:p>
-        </p:txBody>
-      </p:sp>
-      <p:sp>
-        <p:nvSpPr>
-          <p:cNvPr id="10" name="element_7cd7907b726a03416569533f84e11da8"/>
-          <p:cNvSpPr/>
-          <p:nvPr/>
-        </p:nvSpPr>
-        <p:spPr>
-          <a:xfrm>
-            <a:off x="7903876" y="2400300"/>
-            <a:ext cx="121917" cy="2880360"/>
-          </a:xfrm>
-          <a:prstGeom prst="rect">
-            <a:avLst/>
-          </a:prstGeom>
-          <a:solidFill>
-            <a:srgbClr val="DED7CC"/>
-          </a:solidFill>
-          <a:ln w="12700">
-            <a:solidFill>
-              <a:srgbClr val="FFFFFF">
-                <a:alpha val="0"/>
-              </a:srgbClr>
-            </a:solidFill>
-            <a:prstDash val="solid"/>
-          </a:ln>
-        </p:spPr>
-      </p:sp>
-      <p:sp>
-        <p:nvSpPr>
-          <p:cNvPr id="11" name="element_e4ca20bb102ca03a4fd883346de8f290"/>
-          <p:cNvSpPr txBox="1"/>
-          <p:nvPr/>
-        </p:nvSpPr>
-        <p:spPr>
-          <a:xfrm>
-            <a:off x="8086751" y="2400300"/>
-            <a:ext cx="3251525" cy="548640"/>
-          </a:xfrm>
-          <a:prstGeom prst="rect">
-            <a:avLst/>
-          </a:prstGeom>
-          <a:noFill/>
-          <a:ln/>
-        </p:spPr>
-        <p:txBody>
-          <a:bodyPr wrap="square" lIns="0" tIns="0" rIns="0" bIns="0" rtlCol="0" anchor="t">
-            <a:normAutofit/>
-          </a:bodyPr>
-          <a:lstStyle/>
-          <a:p>
-            <a:pPr algn="l" indent="0" marL="0">
-              <a:lnSpc>
-                <a:spcPct val="120000"/>
-              </a:lnSpc>
-              <a:buNone/>
-            </a:pPr>
-            <a:r>
-              <a:rPr lang="en-US" sz="2200" b="1" dirty="0">
-                <a:solidFill>
-                  <a:srgbClr val="B44A2D"/>
-                </a:solidFill>
-                <a:latin typeface="JetBrains Mono Variable" pitchFamily="34" charset="0"/>
-                <a:ea typeface="JetBrains Mono Variable" pitchFamily="34" charset="-122"/>
-                <a:cs typeface="JetBrains Mono Variable" pitchFamily="34" charset="-120"/>
-              </a:rPr>
-              <a:t>03</a:t>
-            </a:r>
-            <a:endParaRPr lang="en-US" sz="2200" dirty="0"/>
-          </a:p>
-        </p:txBody>
-      </p:sp>
-      <p:sp>
-        <p:nvSpPr>
-          <p:cNvPr id="12" name="element_9813dc6398ddba5956c8f55d433b1bf1"/>
-          <p:cNvSpPr txBox="1"/>
-          <p:nvPr/>
-        </p:nvSpPr>
-        <p:spPr>
-          <a:xfrm>
-            <a:off x="8086751" y="2948940"/>
-            <a:ext cx="3251525" cy="2331720"/>
-          </a:xfrm>
-          <a:prstGeom prst="rect">
-            <a:avLst/>
-          </a:prstGeom>
-          <a:noFill/>
-          <a:ln/>
-        </p:spPr>
-        <p:txBody>
-          <a:bodyPr wrap="square" lIns="0" tIns="0" rIns="0" bIns="0" rtlCol="0" anchor="t">
-            <a:normAutofit/>
-          </a:bodyPr>
-          <a:lstStyle/>
-          <a:p>
-            <a:pPr algn="l" indent="0" marL="0">
-              <a:lnSpc>
-                <a:spcPct val="130000"/>
-              </a:lnSpc>
-              <a:buNone/>
-            </a:pPr>
-            <a:r>
-              <a:rPr lang="en-US" sz="1700" dirty="0">
-                <a:solidFill>
-                  <a:srgbClr val="26221D"/>
-                </a:solidFill>
-                <a:latin typeface="Geist Variable" pitchFamily="34" charset="0"/>
-                <a:ea typeface="Geist Variable" pitchFamily="34" charset="-122"/>
-                <a:cs typeface="Geist Variable" pitchFamily="34" charset="-120"/>
-              </a:rPr>
-              <a:t>Name the decision owner and next checkpoint</a:t>
-            </a:r>
-            <a:endParaRPr lang="en-US" sz="1700" dirty="0"/>
-          </a:p>
-        </p:txBody>
-      </p:sp>
-      <p:sp>
-        <p:nvSpPr>
-          <p:cNvPr id="13" name="element_80139f17b05b16ea962bd6c5827bc565"/>
-          <p:cNvSpPr/>
-          <p:nvPr/>
-        </p:nvSpPr>
-        <p:spPr>
-          <a:xfrm>
-            <a:off x="9187662" y="356616"/>
-            <a:ext cx="146300" cy="685800"/>
-          </a:xfrm>
-          <a:prstGeom prst="roundRect">
-            <a:avLst/>
-          </a:prstGeom>
-          <a:solidFill>
-            <a:srgbClr val="34452C">
-              <a:alpha val="54000"/>
-            </a:srgbClr>
-          </a:solidFill>
-          <a:ln w="12700">
-            <a:solidFill>
-              <a:srgbClr val="FFFFFF">
-                <a:alpha val="0"/>
-              </a:srgbClr>
-            </a:solidFill>
-            <a:prstDash val="solid"/>
-          </a:ln>
-        </p:spPr>
-      </p:sp>
-      <p:sp>
-        <p:nvSpPr>
-          <p:cNvPr id="14" name="element_09429fc6a045697dc92d8b9c551a829f"/>
-          <p:cNvSpPr/>
-          <p:nvPr/>
-        </p:nvSpPr>
-        <p:spPr>
-          <a:xfrm>
-            <a:off x="10294667" y="356616"/>
-            <a:ext cx="146300" cy="685800"/>
-          </a:xfrm>
-          <a:prstGeom prst="roundRect">
-            <a:avLst/>
-          </a:prstGeom>
-          <a:solidFill>
-            <a:srgbClr val="34452C">
-              <a:alpha val="54000"/>
-            </a:srgbClr>
-          </a:solidFill>
-          <a:ln w="12700">
-            <a:solidFill>
-              <a:srgbClr val="FFFFFF">
-                <a:alpha val="0"/>
-              </a:srgbClr>
-            </a:solidFill>
-            <a:prstDash val="solid"/>
-          </a:ln>
-        </p:spPr>
-      </p:sp>
-      <p:sp>
-        <p:nvSpPr>
-          <p:cNvPr id="15" name="element_7cafa24ba8e6bd67c7d9638ffc439efa"/>
-          <p:cNvSpPr/>
-          <p:nvPr/>
-        </p:nvSpPr>
-        <p:spPr>
-          <a:xfrm>
-            <a:off x="9333962" y="850392"/>
-            <a:ext cx="960706" cy="68580"/>
-          </a:xfrm>
-          <a:prstGeom prst="roundRect">
-            <a:avLst/>
-          </a:prstGeom>
-          <a:solidFill>
-            <a:srgbClr val="F2DED3">
-              <a:alpha val="57000"/>
-            </a:srgbClr>
-          </a:solidFill>
-          <a:ln w="12700">
-            <a:solidFill>
-              <a:srgbClr val="FFFFFF">
-                <a:alpha val="0"/>
-              </a:srgbClr>
-            </a:solidFill>
-            <a:prstDash val="solid"/>
-          </a:ln>
-        </p:spPr>
-      </p:sp>
-      <p:sp>
-        <p:nvSpPr>
-          <p:cNvPr id="16" name="element_12fee635c3eb15f87ee7f7b760203956"/>
-          <p:cNvSpPr/>
-          <p:nvPr/>
-        </p:nvSpPr>
-        <p:spPr>
-          <a:xfrm>
-            <a:off x="9304702" y="768096"/>
-            <a:ext cx="268217" cy="150876"/>
-          </a:xfrm>
-          <a:prstGeom prst="roundRect">
-            <a:avLst/>
-          </a:prstGeom>
-          <a:solidFill>
-            <a:srgbClr val="B44A2D">
-              <a:alpha val="54000"/>
-            </a:srgbClr>
-          </a:solidFill>
-          <a:ln w="12700">
-            <a:solidFill>
-              <a:srgbClr val="FFFFFF">
-                <a:alpha val="0"/>
-              </a:srgbClr>
-            </a:solidFill>
-            <a:prstDash val="solid"/>
-          </a:ln>
-        </p:spPr>
-      </p:sp>
-      <p:sp>
-        <p:nvSpPr>
-          <p:cNvPr id="17" name="element_9172bfd2dfe4f2b6ae93e28ac873fb18"/>
+            <a:endParaRPr lang="en-US" sz="1600" dirty="0"/>
+          </a:p>
+        </p:txBody>
+      </p:sp>
+      <p:sp>
+        <p:nvSpPr>
+          <p:cNvPr id="12" name="element_9172bfd2dfe4f2b6ae93e28ac873fb18"/>
           <p:cNvSpPr txBox="1"/>
           <p:nvPr/>
         </p:nvSpPr>
@@ -6255,7 +6116,7 @@
       </p:sp>
       <p:sp>
         <p:nvSpPr>
-          <p:cNvPr id="18" name="element_8bdb2720aa1fb4821ec84908bcdb4525"/>
+          <p:cNvPr id="13" name="element_8bdb2720aa1fb4821ec84908bcdb4525"/>
           <p:cNvSpPr txBox="1"/>
           <p:nvPr/>
         </p:nvSpPr>
@@ -6360,14 +6221,159 @@
       </p:sp>
       <p:sp>
         <p:nvSpPr>
-          <p:cNvPr id="3" name="element_70b5d3f8eb26779c32227b9d7aded23e"/>
+          <p:cNvPr id="3" name="element_b83557236440b86c319a667f95d4d550"/>
+          <p:cNvSpPr/>
+          <p:nvPr/>
+        </p:nvSpPr>
+        <p:spPr>
+          <a:xfrm>
+            <a:off x="3291758" y="960120"/>
+            <a:ext cx="5608180" cy="2331720"/>
+          </a:xfrm>
+          <a:prstGeom prst="roundRect">
+            <a:avLst/>
+          </a:prstGeom>
+          <a:solidFill>
+            <a:srgbClr val="F2DED3">
+              <a:alpha val="22000"/>
+            </a:srgbClr>
+          </a:solidFill>
+          <a:ln w="12700">
+            <a:solidFill>
+              <a:srgbClr val="FFFFFF">
+                <a:alpha val="0"/>
+              </a:srgbClr>
+            </a:solidFill>
+            <a:prstDash val="solid"/>
+          </a:ln>
+        </p:spPr>
+      </p:sp>
+      <p:sp>
+        <p:nvSpPr>
+          <p:cNvPr id="4" name="element_b846cd9bc4eb2f58ac9758e24f46d1d2"/>
+          <p:cNvSpPr/>
+          <p:nvPr/>
+        </p:nvSpPr>
+        <p:spPr>
+          <a:xfrm>
+            <a:off x="6901719" y="1335938"/>
+            <a:ext cx="249930" cy="1645920"/>
+          </a:xfrm>
+          <a:prstGeom prst="roundRect">
+            <a:avLst/>
+          </a:prstGeom>
+          <a:solidFill>
+            <a:srgbClr val="34452C">
+              <a:alpha val="62000"/>
+            </a:srgbClr>
+          </a:solidFill>
+          <a:ln w="12700">
+            <a:solidFill>
+              <a:srgbClr val="FFFFFF">
+                <a:alpha val="0"/>
+              </a:srgbClr>
+            </a:solidFill>
+            <a:prstDash val="solid"/>
+          </a:ln>
+        </p:spPr>
+      </p:sp>
+      <p:sp>
+        <p:nvSpPr>
+          <p:cNvPr id="5" name="element_746ebbf3c45d87c1c2255623c24d229b"/>
+          <p:cNvSpPr/>
+          <p:nvPr/>
+        </p:nvSpPr>
+        <p:spPr>
+          <a:xfrm>
+            <a:off x="4829130" y="1335938"/>
+            <a:ext cx="249930" cy="1645920"/>
+          </a:xfrm>
+          <a:prstGeom prst="roundRect">
+            <a:avLst/>
+          </a:prstGeom>
+          <a:solidFill>
+            <a:srgbClr val="34452C">
+              <a:alpha val="62000"/>
+            </a:srgbClr>
+          </a:solidFill>
+          <a:ln w="12700">
+            <a:solidFill>
+              <a:srgbClr val="FFFFFF">
+                <a:alpha val="0"/>
+              </a:srgbClr>
+            </a:solidFill>
+            <a:prstDash val="solid"/>
+          </a:ln>
+        </p:spPr>
+      </p:sp>
+      <p:sp>
+        <p:nvSpPr>
+          <p:cNvPr id="6" name="element_d9a09c6cc4c7c4d4ca167af50ec5cf32"/>
+          <p:cNvSpPr/>
+          <p:nvPr/>
+        </p:nvSpPr>
+        <p:spPr>
+          <a:xfrm>
+            <a:off x="5079060" y="2521001"/>
+            <a:ext cx="1822658" cy="148133"/>
+          </a:xfrm>
+          <a:prstGeom prst="roundRect">
+            <a:avLst/>
+          </a:prstGeom>
+          <a:solidFill>
+            <a:srgbClr val="F2DED3">
+              <a:alpha val="59000"/>
+            </a:srgbClr>
+          </a:solidFill>
+          <a:ln w="12700">
+            <a:solidFill>
+              <a:srgbClr val="FFFFFF">
+                <a:alpha val="0"/>
+              </a:srgbClr>
+            </a:solidFill>
+            <a:prstDash val="solid"/>
+          </a:ln>
+        </p:spPr>
+      </p:sp>
+      <p:sp>
+        <p:nvSpPr>
+          <p:cNvPr id="7" name="element_506bc6b4f43e39e2e0527aa9d15bb098"/>
+          <p:cNvSpPr/>
+          <p:nvPr/>
+        </p:nvSpPr>
+        <p:spPr>
+          <a:xfrm>
+            <a:off x="6075122" y="2323490"/>
+            <a:ext cx="458408" cy="362102"/>
+          </a:xfrm>
+          <a:prstGeom prst="roundRect">
+            <a:avLst/>
+          </a:prstGeom>
+          <a:solidFill>
+            <a:srgbClr val="B44A2D">
+              <a:alpha val="62000"/>
+            </a:srgbClr>
+          </a:solidFill>
+          <a:ln w="12700">
+            <a:solidFill>
+              <a:srgbClr val="FFFFFF">
+                <a:alpha val="0"/>
+              </a:srgbClr>
+            </a:solidFill>
+            <a:prstDash val="solid"/>
+          </a:ln>
+        </p:spPr>
+      </p:sp>
+      <p:sp>
+        <p:nvSpPr>
+          <p:cNvPr id="8" name="element_70b5d3f8eb26779c32227b9d7aded23e"/>
           <p:cNvSpPr txBox="1"/>
           <p:nvPr/>
         </p:nvSpPr>
         <p:spPr>
           <a:xfrm>
-            <a:off x="6461598" y="445770"/>
-            <a:ext cx="4876678" cy="342900"/>
+            <a:off x="7680768" y="445770"/>
+            <a:ext cx="3657509" cy="342900"/>
           </a:xfrm>
           <a:prstGeom prst="rect">
             <a:avLst/>
@@ -6404,14 +6410,14 @@
       </p:sp>
       <p:sp>
         <p:nvSpPr>
-          <p:cNvPr id="4" name="element_8b5e2469f99a96aa74968ebefc93e596"/>
+          <p:cNvPr id="9" name="element_8b5e2469f99a96aa74968ebefc93e596"/>
           <p:cNvSpPr txBox="1"/>
           <p:nvPr/>
         </p:nvSpPr>
         <p:spPr>
           <a:xfrm>
-            <a:off x="853419" y="1097280"/>
-            <a:ext cx="10484858" cy="1234440"/>
+            <a:off x="5242429" y="3909060"/>
+            <a:ext cx="6095848" cy="1577340"/>
           </a:xfrm>
           <a:prstGeom prst="rect">
             <a:avLst/>
@@ -6427,12 +6433,12 @@
           <a:p>
             <a:pPr algn="l" indent="0" marL="0">
               <a:lnSpc>
-                <a:spcPct val="105000"/>
+                <a:spcPct val="104000"/>
               </a:lnSpc>
               <a:buNone/>
             </a:pPr>
             <a:r>
-              <a:rPr lang="en-US" sz="4200" b="1" spc="-60" kern="0" dirty="0">
+              <a:rPr lang="en-US" sz="3400" b="1" spc="-50" kern="0" dirty="0">
                 <a:solidFill>
                   <a:srgbClr val="26221D"/>
                 </a:solidFill>
@@ -6442,20 +6448,20 @@
               </a:rPr>
               <a:t>Start narrow, learn quickly, and preserve room to adapt.</a:t>
             </a:r>
-            <a:endParaRPr lang="en-US" sz="4200" dirty="0"/>
-          </a:p>
-        </p:txBody>
-      </p:sp>
-      <p:sp>
-        <p:nvSpPr>
-          <p:cNvPr id="5" name="element_90b730a1b2c98c39b548c807eb9b5909"/>
+            <a:endParaRPr lang="en-US" sz="3400" dirty="0"/>
+          </a:p>
+        </p:txBody>
+      </p:sp>
+      <p:sp>
+        <p:nvSpPr>
+          <p:cNvPr id="10" name="element_90b730a1b2c98c39b548c807eb9b5909"/>
           <p:cNvSpPr txBox="1"/>
           <p:nvPr/>
         </p:nvSpPr>
         <p:spPr>
           <a:xfrm>
-            <a:off x="1706837" y="2743200"/>
-            <a:ext cx="9631439" cy="1028700"/>
+            <a:off x="853419" y="4046220"/>
+            <a:ext cx="3779426" cy="1097280"/>
           </a:xfrm>
           <a:prstGeom prst="rect">
             <a:avLst/>
@@ -6471,12 +6477,12 @@
           <a:p>
             <a:pPr algn="l" indent="0" marL="0">
               <a:lnSpc>
-                <a:spcPct val="135000"/>
+                <a:spcPct val="138000"/>
               </a:lnSpc>
               <a:buNone/>
             </a:pPr>
             <a:r>
-              <a:rPr lang="en-US" sz="1800" dirty="0">
+              <a:rPr lang="en-US" sz="1500" dirty="0">
                 <a:solidFill>
                   <a:srgbClr val="756B61"/>
                 </a:solidFill>
@@ -6486,20 +6492,20 @@
               </a:rPr>
               <a:t>Sequence the work into a focused launch, an evidence review, and a deliberate scale decision with named ownership at every step.</a:t>
             </a:r>
-            <a:endParaRPr lang="en-US" sz="1800" dirty="0"/>
-          </a:p>
-        </p:txBody>
-      </p:sp>
-      <p:sp>
-        <p:nvSpPr>
-          <p:cNvPr id="6" name="element_8ee0aa206c1a25b5c9fe0405fe23f998"/>
+            <a:endParaRPr lang="en-US" sz="1500" dirty="0"/>
+          </a:p>
+        </p:txBody>
+      </p:sp>
+      <p:sp>
+        <p:nvSpPr>
+          <p:cNvPr id="11" name="element_9349235da7a1a3642195eb55f26192c5"/>
           <p:cNvSpPr txBox="1"/>
           <p:nvPr/>
         </p:nvSpPr>
         <p:spPr>
           <a:xfrm>
-            <a:off x="975336" y="3909060"/>
-            <a:ext cx="4023259" cy="518465"/>
+            <a:off x="853419" y="5280660"/>
+            <a:ext cx="3779426" cy="754380"/>
           </a:xfrm>
           <a:prstGeom prst="rect">
             <a:avLst/>
@@ -6508,239 +6514,35 @@
           <a:ln/>
         </p:spPr>
         <p:txBody>
-          <a:bodyPr wrap="square" lIns="0" tIns="0" rIns="0" bIns="0" rtlCol="0" anchor="t">
+          <a:bodyPr wrap="square" lIns="152400" tIns="152400" rIns="152400" bIns="152400" rtlCol="0" anchor="t">
             <a:normAutofit/>
           </a:bodyPr>
           <a:lstStyle/>
           <a:p>
             <a:pPr algn="l" indent="0" marL="0">
               <a:lnSpc>
-                <a:spcPct val="120000"/>
+                <a:spcPct val="125000"/>
               </a:lnSpc>
               <a:buNone/>
             </a:pPr>
             <a:r>
-              <a:rPr lang="en-US" sz="1700" dirty="0">
+              <a:rPr lang="en-US" sz="1400" b="1" dirty="0">
                 <a:solidFill>
-                  <a:srgbClr val="26221D"/>
+                  <a:srgbClr val="34452C"/>
                 </a:solidFill>
                 <a:latin typeface="Geist Variable" pitchFamily="34" charset="0"/>
                 <a:ea typeface="Geist Variable" pitchFamily="34" charset="-122"/>
                 <a:cs typeface="Geist Variable" pitchFamily="34" charset="-120"/>
               </a:rPr>
-              <a:t>01  Launch the smallest credible move</a:t>
-            </a:r>
-            <a:endParaRPr lang="en-US" sz="1700" dirty="0"/>
-          </a:p>
-        </p:txBody>
-      </p:sp>
-      <p:sp>
-        <p:nvSpPr>
-          <p:cNvPr id="7" name="element_a0b2bd1223cc79d63c445933bf2cc541"/>
-          <p:cNvSpPr txBox="1"/>
-          <p:nvPr/>
-        </p:nvSpPr>
-        <p:spPr>
-          <a:xfrm>
-            <a:off x="975336" y="4633265"/>
-            <a:ext cx="4023259" cy="518465"/>
-          </a:xfrm>
-          <a:prstGeom prst="rect">
-            <a:avLst/>
-          </a:prstGeom>
-          <a:noFill/>
-          <a:ln/>
-        </p:spPr>
-        <p:txBody>
-          <a:bodyPr wrap="square" lIns="0" tIns="0" rIns="0" bIns="0" rtlCol="0" anchor="t">
-            <a:normAutofit/>
-          </a:bodyPr>
-          <a:lstStyle/>
-          <a:p>
-            <a:pPr algn="l" indent="0" marL="0">
-              <a:lnSpc>
-                <a:spcPct val="120000"/>
-              </a:lnSpc>
-              <a:buNone/>
-            </a:pPr>
-            <a:r>
-              <a:rPr lang="en-US" sz="1700" dirty="0">
-                <a:solidFill>
-                  <a:srgbClr val="26221D"/>
-                </a:solidFill>
-                <a:latin typeface="Geist Variable" pitchFamily="34" charset="0"/>
-                <a:ea typeface="Geist Variable" pitchFamily="34" charset="-122"/>
-                <a:cs typeface="Geist Variable" pitchFamily="34" charset="-120"/>
-              </a:rPr>
-              <a:t>02  Review evidence with stakeholders</a:t>
-            </a:r>
-            <a:endParaRPr lang="en-US" sz="1700" dirty="0"/>
-          </a:p>
-        </p:txBody>
-      </p:sp>
-      <p:sp>
-        <p:nvSpPr>
-          <p:cNvPr id="8" name="element_8ed4c22901dde4e39bc7df1eb3e25f7a"/>
-          <p:cNvSpPr txBox="1"/>
-          <p:nvPr/>
-        </p:nvSpPr>
-        <p:spPr>
-          <a:xfrm>
-            <a:off x="975336" y="5356784"/>
-            <a:ext cx="4023259" cy="259232"/>
-          </a:xfrm>
-          <a:prstGeom prst="rect">
-            <a:avLst/>
-          </a:prstGeom>
-          <a:noFill/>
-          <a:ln/>
-        </p:spPr>
-        <p:txBody>
-          <a:bodyPr wrap="square" lIns="0" tIns="0" rIns="0" bIns="0" rtlCol="0" anchor="t">
-            <a:normAutofit/>
-          </a:bodyPr>
-          <a:lstStyle/>
-          <a:p>
-            <a:pPr algn="l" indent="0" marL="0">
-              <a:lnSpc>
-                <a:spcPct val="120000"/>
-              </a:lnSpc>
-              <a:buNone/>
-            </a:pPr>
-            <a:r>
-              <a:rPr lang="en-US" sz="1700" dirty="0">
-                <a:solidFill>
-                  <a:srgbClr val="26221D"/>
-                </a:solidFill>
-                <a:latin typeface="Geist Variable" pitchFamily="34" charset="0"/>
-                <a:ea typeface="Geist Variable" pitchFamily="34" charset="-122"/>
-                <a:cs typeface="Geist Variable" pitchFamily="34" charset="-120"/>
-              </a:rPr>
-              <a:t>03  Scale what earns confidence</a:t>
-            </a:r>
-            <a:endParaRPr lang="en-US" sz="1700" dirty="0"/>
-          </a:p>
-        </p:txBody>
-      </p:sp>
-      <p:sp>
-        <p:nvSpPr>
-          <p:cNvPr id="9" name="element_b846cd9bc4eb2f58ac9758e24f46d1d2"/>
-          <p:cNvSpPr/>
-          <p:nvPr/>
-        </p:nvSpPr>
-        <p:spPr>
-          <a:xfrm>
-            <a:off x="2910158" y="356616"/>
-            <a:ext cx="146300" cy="685800"/>
-          </a:xfrm>
-          <a:prstGeom prst="roundRect">
-            <a:avLst/>
-          </a:prstGeom>
-          <a:solidFill>
-            <a:srgbClr val="34452C">
-              <a:alpha val="62000"/>
-            </a:srgbClr>
-          </a:solidFill>
-          <a:ln w="12700">
-            <a:solidFill>
-              <a:srgbClr val="FFFFFF">
-                <a:alpha val="0"/>
-              </a:srgbClr>
-            </a:solidFill>
-            <a:prstDash val="solid"/>
-          </a:ln>
-        </p:spPr>
-      </p:sp>
-      <p:sp>
-        <p:nvSpPr>
-          <p:cNvPr id="10" name="element_746ebbf3c45d87c1c2255623c24d229b"/>
-          <p:cNvSpPr/>
-          <p:nvPr/>
-        </p:nvSpPr>
-        <p:spPr>
-          <a:xfrm>
-            <a:off x="1697084" y="356616"/>
-            <a:ext cx="146300" cy="685800"/>
-          </a:xfrm>
-          <a:prstGeom prst="roundRect">
-            <a:avLst/>
-          </a:prstGeom>
-          <a:solidFill>
-            <a:srgbClr val="34452C">
-              <a:alpha val="62000"/>
-            </a:srgbClr>
-          </a:solidFill>
-          <a:ln w="12700">
-            <a:solidFill>
-              <a:srgbClr val="FFFFFF">
-                <a:alpha val="0"/>
-              </a:srgbClr>
-            </a:solidFill>
-            <a:prstDash val="solid"/>
-          </a:ln>
-        </p:spPr>
-      </p:sp>
-      <p:sp>
-        <p:nvSpPr>
-          <p:cNvPr id="11" name="element_d9a09c6cc4c7c4d4ca167af50ec5cf32"/>
-          <p:cNvSpPr/>
-          <p:nvPr/>
-        </p:nvSpPr>
-        <p:spPr>
-          <a:xfrm>
-            <a:off x="1843384" y="850392"/>
-            <a:ext cx="1066773" cy="68580"/>
-          </a:xfrm>
-          <a:prstGeom prst="roundRect">
-            <a:avLst/>
-          </a:prstGeom>
-          <a:solidFill>
-            <a:srgbClr val="F2DED3">
-              <a:alpha val="59000"/>
-            </a:srgbClr>
-          </a:solidFill>
-          <a:ln w="12700">
-            <a:solidFill>
-              <a:srgbClr val="FFFFFF">
-                <a:alpha val="0"/>
-              </a:srgbClr>
-            </a:solidFill>
-            <a:prstDash val="solid"/>
-          </a:ln>
-        </p:spPr>
-      </p:sp>
-      <p:sp>
-        <p:nvSpPr>
-          <p:cNvPr id="12" name="element_506bc6b4f43e39e2e0527aa9d15bb098"/>
-          <p:cNvSpPr/>
-          <p:nvPr/>
-        </p:nvSpPr>
-        <p:spPr>
-          <a:xfrm>
-            <a:off x="2426147" y="768096"/>
-            <a:ext cx="268217" cy="150876"/>
-          </a:xfrm>
-          <a:prstGeom prst="roundRect">
-            <a:avLst/>
-          </a:prstGeom>
-          <a:solidFill>
-            <a:srgbClr val="B44A2D">
-              <a:alpha val="62000"/>
-            </a:srgbClr>
-          </a:solidFill>
-          <a:ln w="12700">
-            <a:solidFill>
-              <a:srgbClr val="FFFFFF">
-                <a:alpha val="0"/>
-              </a:srgbClr>
-            </a:solidFill>
-            <a:prstDash val="solid"/>
-          </a:ln>
-        </p:spPr>
-      </p:sp>
-      <p:sp>
-        <p:nvSpPr>
-          <p:cNvPr id="13" name="element_d35232b0ffd5e37581214e15fb92c5ac"/>
+              <a:t>Launch the smallest credible move</a:t>
+            </a:r>
+            <a:endParaRPr lang="en-US" sz="1400" dirty="0"/>
+          </a:p>
+        </p:txBody>
+      </p:sp>
+      <p:sp>
+        <p:nvSpPr>
+          <p:cNvPr id="12" name="element_d35232b0ffd5e37581214e15fb92c5ac"/>
           <p:cNvSpPr txBox="1"/>
           <p:nvPr/>
         </p:nvSpPr>
@@ -6784,7 +6586,7 @@
       </p:sp>
       <p:sp>
         <p:nvSpPr>
-          <p:cNvPr id="14" name="element_a67a90970183e6f2ab7a1b083f879bf6"/>
+          <p:cNvPr id="13" name="element_a67a90970183e6f2ab7a1b083f879bf6"/>
           <p:cNvSpPr txBox="1"/>
           <p:nvPr/>
         </p:nvSpPr>
@@ -7547,8 +7349,8 @@
         </p:nvSpPr>
         <p:spPr>
           <a:xfrm>
-            <a:off x="731502" y="1371600"/>
-            <a:ext cx="5852014" cy="3840480"/>
+            <a:off x="731502" y="1577340"/>
+            <a:ext cx="5608180" cy="3566160"/>
           </a:xfrm>
           <a:prstGeom prst="roundRect">
             <a:avLst/>
@@ -7576,8 +7378,8 @@
         </p:nvSpPr>
         <p:spPr>
           <a:xfrm>
-            <a:off x="2253025" y="1762506"/>
-            <a:ext cx="241396" cy="2400300"/>
+            <a:off x="2296915" y="1977847"/>
+            <a:ext cx="249930" cy="2880360"/>
           </a:xfrm>
           <a:prstGeom prst="roundRect">
             <a:avLst/>
@@ -7605,8 +7407,8 @@
         </p:nvSpPr>
         <p:spPr>
           <a:xfrm>
-            <a:off x="4607242" y="1762506"/>
-            <a:ext cx="241396" cy="2400300"/>
+            <a:off x="4732816" y="1977847"/>
+            <a:ext cx="249930" cy="2880360"/>
           </a:xfrm>
           <a:prstGeom prst="roundRect">
             <a:avLst/>
@@ -7634,8 +7436,8 @@
         </p:nvSpPr>
         <p:spPr>
           <a:xfrm>
-            <a:off x="2494421" y="3490722"/>
-            <a:ext cx="2111602" cy="216027"/>
+            <a:off x="2546845" y="4051706"/>
+            <a:ext cx="2187190" cy="259232"/>
           </a:xfrm>
           <a:prstGeom prst="roundRect">
             <a:avLst/>
@@ -7663,8 +7465,8 @@
         </p:nvSpPr>
         <p:spPr>
           <a:xfrm>
-            <a:off x="3666043" y="3202686"/>
-            <a:ext cx="442559" cy="528066"/>
+            <a:off x="3758700" y="3706063"/>
+            <a:ext cx="458408" cy="633679"/>
           </a:xfrm>
           <a:prstGeom prst="roundRect">
             <a:avLst/>
@@ -7824,8 +7626,8 @@
         </p:nvSpPr>
         <p:spPr>
           <a:xfrm>
-            <a:off x="7315017" y="5417820"/>
-            <a:ext cx="4145176" cy="548640"/>
+            <a:off x="7315017" y="5280660"/>
+            <a:ext cx="4145176" cy="754380"/>
           </a:xfrm>
           <a:prstGeom prst="rect">
             <a:avLst/>

</xml_diff>